<commit_message>
Explain TwitterAAE selection and evaluation in natural Japanese
</commit_message>
<xml_diff>
--- a/slides/datasets-in-10-minutes-twitter-aae.pptx
+++ b/slides/datasets-in-10-minutes-twitter-aae.pptx
@@ -49,7 +49,6 @@
     <p:sldId id="297" r:id="rId47"/>
     <p:sldId id="298" r:id="rId48"/>
     <p:sldId id="299" r:id="rId49"/>
-    <p:sldId id="300" r:id="rId50"/>
     <p:sldId id="301" r:id="rId51"/>
     <p:sldId id="302" r:id="rId52"/>
     <p:sldId id="303" r:id="rId53"/>
@@ -7407,7 +7406,7 @@
                 <a:ea typeface="Noto Sans CJK JP"/>
                 <a:cs typeface="Noto Sans"/>
               </a:rPr>
-              <a:t>実例3：white側にもくだけた会話がある</a:t>
+              <a:t>実例3：white側にも語りかけの表現がある</a:t>
             </a:r>
           </a:p>
         </p:txBody>
@@ -7522,8 +7521,8 @@
         </p:nvSpPr>
         <p:spPr>
           <a:xfrm>
-            <a:off x="548640" y="1673352"/>
-            <a:ext cx="8046720" cy="601598"/>
+            <a:off x="548640" y="1756833"/>
+            <a:ext cx="8046720" cy="465667"/>
           </a:xfrm>
           <a:prstGeom prst="rect">
             <a:avLst/>
@@ -7551,7 +7550,7 @@
           </a:fontRef>
         </p:style>
         <p:txBody>
-          <a:bodyPr rtlCol="0" anchor="t" wrap="square" lIns="177800" rIns="177800" tIns="101600" bIns="127000">
+          <a:bodyPr rtlCol="0" anchor="t" wrap="square" lIns="177800" rIns="177800" tIns="18119" bIns="127000">
             <a:noAutofit/>
           </a:bodyPr>
           <a:lstStyle/>
@@ -7596,7 +7595,7 @@
         </p:nvSpPr>
         <p:spPr>
           <a:xfrm>
-            <a:off x="594360" y="2476119"/>
+            <a:off x="594360" y="2423670"/>
             <a:ext cx="7955279" cy="228600"/>
           </a:xfrm>
           <a:prstGeom prst="rect">
@@ -7650,7 +7649,7 @@
         </p:nvSpPr>
         <p:spPr>
           <a:xfrm>
-            <a:off x="594360" y="2777871"/>
+            <a:off x="594360" y="2725422"/>
             <a:ext cx="7955279" cy="378206"/>
           </a:xfrm>
           <a:prstGeom prst="rect">
@@ -7704,7 +7703,7 @@
         </p:nvSpPr>
         <p:spPr>
           <a:xfrm>
-            <a:off x="594360" y="3338957"/>
+            <a:off x="594360" y="3286508"/>
             <a:ext cx="7955279" cy="594360"/>
           </a:xfrm>
           <a:prstGeom prst="rect">
@@ -7799,22 +7798,8 @@
                 <a:ea typeface="Noto Sans CJK JP"/>
                 <a:cs typeface="Noto Sans"/>
               </a:rPr>
-              <a:t>[1] Stanford CRFM, HELM Classic v0.4.0, TwitterAAE. 公開実行suite v0.3.0。 instance: white/id12363（HELM内ID）</a:t>
-            </a:r>
-          </a:p>
-          <a:p>
-            <a:pPr>
-              <a:lnSpc>
-                <a:spcPts val="940"/>
-              </a:lnSpc>
-              <a:buNone/>
-              <a:defRPr sz="810" b="0">
-                <a:solidFill>
-                  <a:srgbClr val="303437"/>
-                </a:solidFill>
-                <a:latin typeface="Noto Sans"/>
-              </a:defRPr>
-            </a:pPr>
+              <a:t>[1] Stanford CRFM. HELM Classic v0.4.0 — TwitterAAE.  </a:t>
+            </a:r>
             <a:r>
               <a:rPr sz="810" b="0" lang="ja-JP" altLang="en-US">
                 <a:solidFill>
@@ -8161,7 +8146,7 @@
                 <a:ea typeface="Noto Sans CJK JP"/>
                 <a:cs typeface="Noto Sans"/>
               </a:rPr>
-              <a:t>フォロワー1,000人以上の著者、3個以上のハッシュタグ、http・follow・mentionを含む投稿、リツイートなどを除いた。</a:t>
+              <a:t>フォロワーの多いアカウントや、ハッシュタグの多い投稿、リンク・宣伝語を含む投稿、リツイートなどを除いた。</a:t>
             </a:r>
           </a:p>
         </p:txBody>
@@ -8571,7 +8556,7 @@
                 <a:ea typeface="Noto Sans CJK JP"/>
                 <a:cs typeface="Noto Sans"/>
               </a:rPr>
-              <a:t>これは近隣地域の人口構成を介した遠隔教師信号。個人に人種を尋ねた注釈は付けていない。</a:t>
+              <a:t>近隣地域の人口構成を、投稿の言語的特徴を推定する手掛かりにする。</a:t>
             </a:r>
           </a:p>
         </p:txBody>
@@ -8873,7 +8858,7 @@
                 <a:ea typeface="Noto Sans CJK JP"/>
                 <a:cs typeface="Noto Sans"/>
               </a:rPr>
-              <a:t>同じ人が投稿ごとに異なる表現を使える設計。特定のキーワードを一度使っただけで、その人の全投稿を同じ言語に固定しない。</a:t>
+              <a:t>同じ人でも、投稿によって使う表現は変わる。ユーザー単位と投稿単位の混合比で、その変化を表現する。</a:t>
             </a:r>
           </a:p>
         </p:txBody>
@@ -9019,7 +9004,7 @@
                 <a:ea typeface="Noto Sans CJK JP"/>
                 <a:cs typeface="Noto Sans"/>
               </a:rPr>
-              <a:t>言語的特徴との対応を確かめた</a:t>
+              <a:t>AAEに特徴的な文法が多く現れる</a:t>
             </a:r>
           </a:p>
         </p:txBody>
@@ -9936,7 +9921,7 @@
                 <a:ea typeface="Noto Sans CJK JP"/>
                 <a:cs typeface="Noto Sans"/>
               </a:rPr>
-              <a:t>2016年の集合とHELMの集合は作り方が違う</a:t>
+              <a:t>HELMは、投稿ごとの言語的特徴で集合を作る</a:t>
             </a:r>
           </a:p>
         </p:txBody>
@@ -9999,7 +9984,7 @@
         </p:nvGraphicFramePr>
         <p:xfrm>
           <a:off x="548640" y="1508760"/>
-          <a:ext cx="8046720" cy="1729994"/>
+          <a:ext cx="8046720" cy="2176272"/>
         </p:xfrm>
         <a:graphic>
           <a:graphicData uri="http://schemas.openxmlformats.org/drawingml/2006/table">
@@ -10009,7 +9994,7 @@
                 <a:gridCol w="2331720"/>
                 <a:gridCol w="5715000"/>
               </a:tblGrid>
-              <a:tr h="420624">
+              <a:tr h="438912">
                 <a:tc>
                   <a:txBody>
                     <a:bodyPr wrap="square">
@@ -10123,7 +10108,7 @@
                   </a:tcPr>
                 </a:tc>
               </a:tr>
-              <a:tr h="654685">
+              <a:tr h="868680">
                 <a:tc>
                   <a:txBody>
                     <a:bodyPr wrap="square">
@@ -10205,7 +10190,7 @@
                           <a:ea typeface="Noto Sans CJK JP"/>
                           <a:cs typeface="Noto Sans"/>
                         </a:rPr>
-                        <a:t>ユーザーの対応言語比率80%以上、他2成分の合計5%未満。AA約83万／white約730万投稿。</a:t>
+                        <a:t>ユーザーの対応言語成分80%以上、ヒスパニック系・アジア系は計5%未満。AA約83万／white約730万投稿。</a:t>
                       </a:r>
                     </a:p>
                   </a:txBody>
@@ -10231,7 +10216,7 @@
                   </a:tcPr>
                 </a:tc>
               </a:tr>
-              <a:tr h="654685">
+              <a:tr h="868680">
                 <a:tc>
                   <a:txBody>
                     <a:bodyPr wrap="square">
@@ -10351,8 +10336,8 @@
         </p:nvSpPr>
         <p:spPr>
           <a:xfrm>
-            <a:off x="594360" y="3439922"/>
-            <a:ext cx="7955279" cy="658368"/>
+            <a:off x="594360" y="3886200"/>
+            <a:ext cx="7955279" cy="548640"/>
           </a:xfrm>
           <a:prstGeom prst="rect">
             <a:avLst/>
@@ -10392,7 +10377,7 @@
                 <a:ea typeface="Noto Sans CJK JP"/>
                 <a:cs typeface="Noto Sans"/>
               </a:rPr>
-              <a:t>HELMの公開コードが記載する二段階の抽出。2016年の解析集合をそのまま5万件にしたものではない。</a:t>
+              <a:t>2016年の分析はユーザーごとに選び、HELMは投稿ごとの混合比で選ぶ。</a:t>
             </a:r>
           </a:p>
         </p:txBody>
@@ -10446,7 +10431,7 @@
                 <a:ea typeface="Noto Sans CJK JP"/>
                 <a:cs typeface="Noto Sans"/>
               </a:rPr>
-              <a:t>[1] Stanford CRFM, HELM TwitterAAEScenario. AA／whiteの抽出とtestインスタンス。2026-10-18確認。</a:t>
+              <a:t>[1] Stanford CRFM, HELM TwitterAAEScenario. </a:t>
             </a:r>
           </a:p>
           <a:p>
@@ -10462,6 +10447,17 @@
                 <a:latin typeface="Noto Sans"/>
               </a:defRPr>
             </a:pPr>
+            <a:r>
+              <a:rPr sz="810" b="0" lang="ja-JP" altLang="en-US">
+                <a:solidFill>
+                  <a:srgbClr val="626669"/>
+                </a:solidFill>
+                <a:latin typeface="Noto Sans"/>
+                <a:ea typeface="Noto Sans CJK JP"/>
+                <a:cs typeface="Noto Sans"/>
+              </a:rPr>
+              <a:t/>
+            </a:r>
             <a:r>
               <a:rPr sz="810" b="0" lang="ja-JP" altLang="en-US">
                 <a:solidFill>
@@ -10652,7 +10648,7 @@
                 <a:ea typeface="Noto Sans CJK JP"/>
                 <a:cs typeface="Noto Sans"/>
               </a:rPr>
-              <a:t>低いbits per byteほど投稿を予測できる</a:t>
+              <a:t>BPBが低いほど、投稿を予測しやすい</a:t>
             </a:r>
           </a:p>
         </p:txBody>
@@ -10754,7 +10750,7 @@
                 <a:ea typeface="Noto Sans CJK JP"/>
                 <a:cs typeface="Noto Sans"/>
               </a:rPr>
-              <a:t>言語モデルは、先行する文字列を条件に各トークンの確率を付ける。予測対象の対数確率を合計し、そのbyte数で割ってbitsへ換算する。</a:t>
+              <a:t>言語モデルは、先行する文字列を条件に各トークンの確率を付ける。予測対象の負の対数確率を合計し、そのbyte数で割ってbitsへ換算する。</a:t>
             </a:r>
           </a:p>
         </p:txBody>
@@ -10916,7 +10912,7 @@
                 <a:ea typeface="Noto Sans CJK JP"/>
                 <a:cs typeface="Noto Sans"/>
               </a:rPr>
-              <a:t>[1] Stanford CRFM, HELM BasicMetrics. 対数確率・byte数からの集約。2026-10-18確認。</a:t>
+              <a:t>[1] Stanford CRFM, HELM BasicMetrics. </a:t>
             </a:r>
           </a:p>
           <a:p>
@@ -10932,6 +10928,17 @@
                 <a:latin typeface="Noto Sans"/>
               </a:defRPr>
             </a:pPr>
+            <a:r>
+              <a:rPr sz="810" b="0" lang="ja-JP" altLang="en-US">
+                <a:solidFill>
+                  <a:srgbClr val="626669"/>
+                </a:solidFill>
+                <a:latin typeface="Noto Sans"/>
+                <a:ea typeface="Noto Sans CJK JP"/>
+                <a:cs typeface="Noto Sans"/>
+              </a:rPr>
+              <a:t/>
+            </a:r>
             <a:r>
               <a:rPr sz="810" b="0" lang="ja-JP" altLang="en-US">
                 <a:solidFill>
@@ -11790,7 +11797,7 @@
                 <a:ea typeface="Noto Sans CJK JP"/>
                 <a:cs typeface="Noto Sans"/>
               </a:rPr>
-              <a:t>BPB、低いほど良い。Classic v0.4.0収録・suite v0.3.0、各条件1,000投稿、提示例0、各1試行。</a:t>
+              <a:t>BPB（低いほど良い）。2022年公開の2モデルを、AA・white各1,000投稿で比較。提示例なし。</a:t>
             </a:r>
           </a:p>
         </p:txBody>
@@ -11844,18 +11851,7 @@
                 <a:ea typeface="Noto Sans CJK JP"/>
                 <a:cs typeface="Noto Sans"/>
               </a:rPr>
-              <a:t>[1] Stanford CRFM, HELM Classic v0.4.0, TwitterAAE. 公開実行suite v0.3.0。</a:t>
-            </a:r>
-            <a:r>
-              <a:rPr sz="810" b="0" lang="ja-JP" altLang="en-US">
-                <a:solidFill>
-                  <a:srgbClr val="626669"/>
-                </a:solidFill>
-                <a:latin typeface="Noto Sans"/>
-                <a:ea typeface="Noto Sans CJK JP"/>
-                <a:cs typeface="Noto Sans"/>
-              </a:rPr>
-              <a:t>  </a:t>
+              <a:t>[1] Stanford CRFM. HELM Classic v0.4.0 — TwitterAAE.  </a:t>
             </a:r>
             <a:r>
               <a:rPr sz="810" b="0" lang="ja-JP" altLang="en-US">
@@ -12059,18 +12055,7 @@
                 <a:ea typeface="Noto Sans CJK JP"/>
                 <a:cs typeface="Noto Sans"/>
               </a:rPr>
-              <a:t>[1] UMass SLANG Lab (n.d.), TwitterAAE: Research on African-American English on Twitter. 2026-10-18参照。</a:t>
-            </a:r>
-            <a:r>
-              <a:rPr sz="810" b="0" lang="ja-JP" altLang="en-US">
-                <a:solidFill>
-                  <a:srgbClr val="626669"/>
-                </a:solidFill>
-                <a:latin typeface="Noto Sans"/>
-                <a:ea typeface="Noto Sans CJK JP"/>
-                <a:cs typeface="Noto Sans"/>
-              </a:rPr>
-              <a:t>  </a:t>
+              <a:t>[1] UMass SLANG Lab (n.d.), TwitterAAE: Research on African-American English on Twitter. </a:t>
             </a:r>
             <a:r>
               <a:rPr sz="810" b="0" lang="ja-JP" altLang="en-US">
@@ -12148,7 +12133,7 @@
                 <a:ea typeface="Noto Sans CJK JP"/>
                 <a:cs typeface="Noto Sans"/>
               </a:rPr>
-              <a:t>得点差は、二つの抽出集合での予測の差</a:t>
+              <a:t>AA側の投稿では、両モデルとも予測が難しい</a:t>
             </a:r>
           </a:p>
         </p:txBody>
@@ -12304,21 +12289,21 @@
                 <a:ea typeface="Noto Sans CJK JP"/>
                 <a:cs typeface="Noto Sans"/>
               </a:rPr>
-              <a:t>集合にはつづり、話題、長さ、会話の形式などの違いも含まれる。同じ内容だけを方言で書き換えた対訳実験ではない。</a:t>
-            </a:r>
-          </a:p>
-        </p:txBody>
-      </p:sp>
-      <p:sp>
-        <p:nvSpPr>
-          <p:cNvPr id="6" name="TextBox 5"/>
+              <a:t>二つの集合には、つづり・話題・長さ・会話の形式などの違いがある。得点差には、こうした内容や表現の違いが含まれる。</a:t>
+            </a:r>
+          </a:p>
+        </p:txBody>
+      </p:sp>
+      <p:sp>
+        <p:nvSpPr>
+          <p:cNvPr id="7" name="sources"/>
           <p:cNvSpPr txBox="1"/>
           <p:nvPr/>
         </p:nvSpPr>
         <p:spPr>
           <a:xfrm>
-            <a:off x="594360" y="3153156"/>
-            <a:ext cx="7955279" cy="680466"/>
+            <a:off x="502920" y="4700016"/>
+            <a:ext cx="8183879" cy="530352"/>
           </a:xfrm>
           <a:prstGeom prst="rect">
             <a:avLst/>
@@ -12333,60 +12318,6 @@
           <a:p>
             <a:pPr algn="l">
               <a:lnSpc>
-                <a:spcPts val="2499"/>
-              </a:lnSpc>
-              <a:spcBef>
-                <a:spcPts val="0"/>
-              </a:spcBef>
-              <a:spcAft>
-                <a:spcPts val="0"/>
-              </a:spcAft>
-              <a:buNone/>
-              <a:defRPr sz="2100" b="0">
-                <a:solidFill>
-                  <a:srgbClr val="303437"/>
-                </a:solidFill>
-                <a:latin typeface="Noto Sans"/>
-              </a:defRPr>
-            </a:pPr>
-            <a:r>
-              <a:rPr sz="2100" b="0" lang="ja-JP" altLang="en-US">
-                <a:solidFill>
-                  <a:srgbClr val="303437"/>
-                </a:solidFill>
-                <a:latin typeface="Noto Sans"/>
-                <a:ea typeface="Noto Sans CJK JP"/>
-                <a:cs typeface="Noto Sans"/>
-              </a:rPr>
-              <a:t>この値が示すのは公開実行時の投稿集合での差であり、2026年のモデルの順位ではない。</a:t>
-            </a:r>
-          </a:p>
-        </p:txBody>
-      </p:sp>
-      <p:sp>
-        <p:nvSpPr>
-          <p:cNvPr id="7" name="sources"/>
-          <p:cNvSpPr txBox="1"/>
-          <p:nvPr/>
-        </p:nvSpPr>
-        <p:spPr>
-          <a:xfrm>
-            <a:off x="502920" y="4700016"/>
-            <a:ext cx="8183879" cy="530352"/>
-          </a:xfrm>
-          <a:prstGeom prst="rect">
-            <a:avLst/>
-          </a:prstGeom>
-          <a:noFill/>
-        </p:spPr>
-        <p:txBody>
-          <a:bodyPr wrap="square" lIns="0" rIns="0" tIns="0" bIns="0">
-            <a:noAutofit/>
-          </a:bodyPr>
-          <a:lstStyle/>
-          <a:p>
-            <a:pPr algn="l">
-              <a:lnSpc>
                 <a:spcPts val="940"/>
               </a:lnSpc>
               <a:spcBef>
@@ -12412,18 +12343,7 @@
                 <a:ea typeface="Noto Sans CJK JP"/>
                 <a:cs typeface="Noto Sans"/>
               </a:rPr>
-              <a:t>[1] Stanford CRFM, HELM Classic v0.4.0, TwitterAAE. 公開実行suite v0.3.0。</a:t>
-            </a:r>
-            <a:r>
-              <a:rPr sz="810" b="0" lang="ja-JP" altLang="en-US">
-                <a:solidFill>
-                  <a:srgbClr val="626669"/>
-                </a:solidFill>
-                <a:latin typeface="Noto Sans"/>
-                <a:ea typeface="Noto Sans CJK JP"/>
-                <a:cs typeface="Noto Sans"/>
-              </a:rPr>
-              <a:t>  </a:t>
+              <a:t>[1] Stanford CRFM. HELM Classic v0.4.0 — TwitterAAE.  </a:t>
             </a:r>
             <a:r>
               <a:rPr sz="810" b="0" lang="ja-JP" altLang="en-US">
@@ -13181,7 +13101,7 @@
                 <a:ea typeface="Noto Sans CJK JP"/>
                 <a:cs typeface="Noto Sans"/>
               </a:rPr>
-              <a:t>HELM Classicは別途抽出した投稿を言語モデリングに用いる。2026-10-18確認の公開実装にもAA／whiteの両条件が残る。</a:t>
+              <a:t>HELM Classicでは、同じ元コーパスから投稿を別途抽出し、言語モデルの予測しやすさを比べる評価へ広がった。</a:t>
             </a:r>
           </a:p>
         </p:txBody>
@@ -13259,6 +13179,17 @@
                 <a:latin typeface="Noto Sans"/>
                 <a:ea typeface="Noto Sans CJK JP"/>
                 <a:cs typeface="Noto Sans"/>
+              </a:rPr>
+              <a:t/>
+            </a:r>
+            <a:r>
+              <a:rPr sz="810" b="0" lang="ja-JP" altLang="en-US">
+                <a:solidFill>
+                  <a:srgbClr val="626669"/>
+                </a:solidFill>
+                <a:latin typeface="Noto Sans"/>
+                <a:ea typeface="Noto Sans CJK JP"/>
+                <a:cs typeface="Noto Sans"/>
                 <a:hlinkClick r:id="rId2"/>
               </a:rPr>
               <a:t>https://aclanthology.org/P18-1131/</a:t>
@@ -13289,7 +13220,7 @@
                 <a:ea typeface="Noto Sans CJK JP"/>
                 <a:cs typeface="Noto Sans"/>
               </a:rPr>
-              <a:t>[2] Stanford CRFM, HELM TwitterAAEScenario. AA／whiteの抽出とtestインスタンス。2026-10-18確認。</a:t>
+              <a:t>[2] Stanford CRFM, HELM TwitterAAEScenario. </a:t>
             </a:r>
           </a:p>
           <a:p>
@@ -13305,6 +13236,17 @@
                 <a:latin typeface="Noto Sans"/>
               </a:defRPr>
             </a:pPr>
+            <a:r>
+              <a:rPr sz="810" b="0" lang="ja-JP" altLang="en-US">
+                <a:solidFill>
+                  <a:srgbClr val="626669"/>
+                </a:solidFill>
+                <a:latin typeface="Noto Sans"/>
+                <a:ea typeface="Noto Sans CJK JP"/>
+                <a:cs typeface="Noto Sans"/>
+              </a:rPr>
+              <a:t/>
+            </a:r>
             <a:r>
               <a:rPr sz="810" b="0" lang="ja-JP" altLang="en-US">
                 <a:solidFill>
@@ -13381,7 +13323,7 @@
                 <a:ea typeface="Noto Sans CJK JP"/>
                 <a:cs typeface="Noto Sans"/>
               </a:rPr>
-              <a:t>公式配布とHELMの公開記録を使い分ける</a:t>
+              <a:t>研究用コーパスと評価結果を公式サイトで入手する</a:t>
             </a:r>
           </a:p>
         </p:txBody>
@@ -13537,7 +13479,7 @@
                 <a:ea typeface="Noto Sans CJK JP"/>
                 <a:cs typeface="Noto Sans"/>
               </a:rPr>
-              <a:t>HELMの5万件CSVはCodaLabのURLを参照する。今回の取得では双方503となったが、公開実行の1,000投稿ずつと得点は取得できた。</a:t>
+              <a:t>HELMはAA・white各5万投稿のCSVを案内し、Classicの評価ページで、実際に使った投稿とモデルの得点を公開している。</a:t>
             </a:r>
           </a:p>
         </p:txBody>
@@ -13591,7 +13533,7 @@
                 <a:ea typeface="Noto Sans CJK JP"/>
                 <a:cs typeface="Noto Sans"/>
               </a:rPr>
-              <a:t>推定モデルのコードにはMITライセンスがある。投稿本文の権利や再配布範囲は、コードのMITライセンスとは別に扱う。</a:t>
+              <a:t>推定モデルのコードはMITライセンス。投稿本文の利用は、公式サイトの研究目的という条件と、元投稿の権利を確認する。</a:t>
             </a:r>
           </a:p>
         </p:txBody>
@@ -13645,18 +13587,7 @@
                 <a:ea typeface="Noto Sans CJK JP"/>
                 <a:cs typeface="Noto Sans"/>
               </a:rPr>
-              <a:t>[1] UMass SLANG Lab (n.d.), TwitterAAE: Research on African-American English on Twitter. 2026-10-18参照。</a:t>
-            </a:r>
-            <a:r>
-              <a:rPr sz="810" b="0" lang="ja-JP" altLang="en-US">
-                <a:solidFill>
-                  <a:srgbClr val="626669"/>
-                </a:solidFill>
-                <a:latin typeface="Noto Sans"/>
-                <a:ea typeface="Noto Sans CJK JP"/>
-                <a:cs typeface="Noto Sans"/>
-              </a:rPr>
-              <a:t>  </a:t>
+              <a:t>[1] UMass SLANG Lab (n.d.), TwitterAAE: Research on African-American English on Twitter. </a:t>
             </a:r>
             <a:r>
               <a:rPr sz="810" b="0" lang="ja-JP" altLang="en-US">
@@ -13890,7 +13821,7 @@
                 <a:ea typeface="Noto Sans CJK JP"/>
                 <a:cs typeface="Noto Sans"/>
               </a:rPr>
-              <a:t>HELMは、同じコーパスから二つの言語抽出集合を作り、それぞれの投稿に対するBPBを比べる。</a:t>
+              <a:t>HELMは、同じコーパスから言語的特徴で選んだ二つの投稿集合を作り、それぞれの投稿に対するBPBを比べる。</a:t>
             </a:r>
           </a:p>
         </p:txBody>
@@ -13944,7 +13875,7 @@
                 <a:ea typeface="Noto Sans CJK JP"/>
                 <a:cs typeface="Noto Sans"/>
               </a:rPr>
-              <a:t>元の集合の作り方と公開実行の範囲を押さえると、投稿の予測しにくさと、既存NLP処理の取りこぼしを具体的に捉えられる。</a:t>
+              <a:t>言語モデルの予測しやすさと、言語同定による取りこぼしを調べることで、NLPが扱える会話の範囲を見直せる。</a:t>
             </a:r>
           </a:p>
         </p:txBody>
@@ -14284,7 +14215,7 @@
                 <a:ea typeface="Noto Sans CJK JP"/>
                 <a:cs typeface="Noto Sans"/>
               </a:rPr>
-              <a:t>版・実行条件の補足</a:t>
+              <a:t>入力と指標の補足</a:t>
             </a:r>
           </a:p>
           <a:p>
@@ -14657,8 +14588,8 @@
         </p:nvSpPr>
         <p:spPr>
           <a:xfrm>
-            <a:off x="548640" y="1673352"/>
-            <a:ext cx="8046720" cy="601598"/>
+            <a:off x="548640" y="1756833"/>
+            <a:ext cx="8046720" cy="465667"/>
           </a:xfrm>
           <a:prstGeom prst="rect">
             <a:avLst/>
@@ -14686,7 +14617,7 @@
           </a:fontRef>
         </p:style>
         <p:txBody>
-          <a:bodyPr rtlCol="0" anchor="t" wrap="square" lIns="177800" rIns="177800" tIns="101600" bIns="127000">
+          <a:bodyPr rtlCol="0" anchor="t" wrap="square" lIns="177800" rIns="177800" tIns="18119" bIns="127000">
             <a:noAutofit/>
           </a:bodyPr>
           <a:lstStyle/>
@@ -14731,7 +14662,7 @@
         </p:nvSpPr>
         <p:spPr>
           <a:xfrm>
-            <a:off x="594360" y="2476119"/>
+            <a:off x="594360" y="2423670"/>
             <a:ext cx="7955279" cy="228600"/>
           </a:xfrm>
           <a:prstGeom prst="rect">
@@ -14785,7 +14716,7 @@
         </p:nvSpPr>
         <p:spPr>
           <a:xfrm>
-            <a:off x="594360" y="2777871"/>
+            <a:off x="594360" y="2725422"/>
             <a:ext cx="7955279" cy="378206"/>
           </a:xfrm>
           <a:prstGeom prst="rect">
@@ -14839,7 +14770,7 @@
         </p:nvSpPr>
         <p:spPr>
           <a:xfrm>
-            <a:off x="594360" y="3338957"/>
+            <a:off x="594360" y="3286508"/>
             <a:ext cx="7955279" cy="594360"/>
           </a:xfrm>
           <a:prstGeom prst="rect">
@@ -14880,7 +14811,7 @@
                 <a:ea typeface="Noto Sans CJK JP"/>
                 <a:cs typeface="Noto Sans"/>
               </a:rPr>
-              <a:t>何を数えているかは、この投稿だけでは分からない。</a:t>
+              <a:t>終わった数と残りの数を、短い対比で伝える。</a:t>
             </a:r>
           </a:p>
         </p:txBody>
@@ -14934,22 +14865,8 @@
                 <a:ea typeface="Noto Sans CJK JP"/>
                 <a:cs typeface="Noto Sans"/>
               </a:rPr>
-              <a:t>[1] Stanford CRFM, HELM Classic v0.4.0, TwitterAAE. 公開実行suite v0.3.0。 instance: aa/id42642（HELM内ID）</a:t>
-            </a:r>
-          </a:p>
-          <a:p>
-            <a:pPr>
-              <a:lnSpc>
-                <a:spcPts val="940"/>
-              </a:lnSpc>
-              <a:buNone/>
-              <a:defRPr sz="810" b="0">
-                <a:solidFill>
-                  <a:srgbClr val="303437"/>
-                </a:solidFill>
-                <a:latin typeface="Noto Sans"/>
-              </a:defRPr>
-            </a:pPr>
+              <a:t>[1] Stanford CRFM. HELM Classic v0.4.0 — TwitterAAE.  </a:t>
+            </a:r>
             <a:r>
               <a:rPr sz="810" b="0" lang="ja-JP" altLang="en-US">
                 <a:solidFill>
@@ -15398,8 +15315,8 @@
         </p:nvSpPr>
         <p:spPr>
           <a:xfrm>
-            <a:off x="548640" y="1673352"/>
-            <a:ext cx="8046720" cy="601598"/>
+            <a:off x="548640" y="1756833"/>
+            <a:ext cx="8046720" cy="465667"/>
           </a:xfrm>
           <a:prstGeom prst="rect">
             <a:avLst/>
@@ -15427,7 +15344,7 @@
           </a:fontRef>
         </p:style>
         <p:txBody>
-          <a:bodyPr rtlCol="0" anchor="t" wrap="square" lIns="177800" rIns="177800" tIns="101600" bIns="127000">
+          <a:bodyPr rtlCol="0" anchor="t" wrap="square" lIns="177800" rIns="177800" tIns="18119" bIns="127000">
             <a:noAutofit/>
           </a:bodyPr>
           <a:lstStyle/>
@@ -15472,7 +15389,7 @@
         </p:nvSpPr>
         <p:spPr>
           <a:xfrm>
-            <a:off x="594360" y="2476119"/>
+            <a:off x="594360" y="2423670"/>
             <a:ext cx="7955279" cy="228600"/>
           </a:xfrm>
           <a:prstGeom prst="rect">
@@ -15526,7 +15443,7 @@
         </p:nvSpPr>
         <p:spPr>
           <a:xfrm>
-            <a:off x="594360" y="2777871"/>
+            <a:off x="594360" y="2725422"/>
             <a:ext cx="7955279" cy="378206"/>
           </a:xfrm>
           <a:prstGeom prst="rect">
@@ -15580,7 +15497,7 @@
         </p:nvSpPr>
         <p:spPr>
           <a:xfrm>
-            <a:off x="594360" y="3338957"/>
+            <a:off x="594360" y="3286508"/>
             <a:ext cx="7955279" cy="594360"/>
           </a:xfrm>
           <a:prstGeom prst="rect">
@@ -15621,7 +15538,7 @@
                 <a:ea typeface="Noto Sans CJK JP"/>
                 <a:cs typeface="Noto Sans"/>
               </a:rPr>
-              <a:t>afの強調を、日本語でも強い話し言葉で表した。</a:t>
+              <a:t>afは強い強調を加える俗語。hungryと組み合わせ、空腹の強さを伝える。</a:t>
             </a:r>
           </a:p>
         </p:txBody>
@@ -15675,22 +15592,8 @@
                 <a:ea typeface="Noto Sans CJK JP"/>
                 <a:cs typeface="Noto Sans"/>
               </a:rPr>
-              <a:t>[1] Stanford CRFM, HELM Classic v0.4.0, TwitterAAE. 公開実行suite v0.3.0。 instance: aa/id8369（HELM内ID）</a:t>
-            </a:r>
-          </a:p>
-          <a:p>
-            <a:pPr>
-              <a:lnSpc>
-                <a:spcPts val="940"/>
-              </a:lnSpc>
-              <a:buNone/>
-              <a:defRPr sz="810" b="0">
-                <a:solidFill>
-                  <a:srgbClr val="303437"/>
-                </a:solidFill>
-                <a:latin typeface="Noto Sans"/>
-              </a:defRPr>
-            </a:pPr>
+              <a:t>[1] Stanford CRFM. HELM Classic v0.4.0 — TwitterAAE.  </a:t>
+            </a:r>
             <a:r>
               <a:rPr sz="810" b="0" lang="ja-JP" altLang="en-US">
                 <a:solidFill>
@@ -15882,8 +15785,8 @@
         </p:nvSpPr>
         <p:spPr>
           <a:xfrm>
-            <a:off x="548640" y="1673352"/>
-            <a:ext cx="8046720" cy="601598"/>
+            <a:off x="548640" y="1756833"/>
+            <a:ext cx="8046720" cy="397934"/>
           </a:xfrm>
           <a:prstGeom prst="rect">
             <a:avLst/>
@@ -15911,7 +15814,7 @@
           </a:fontRef>
         </p:style>
         <p:txBody>
-          <a:bodyPr rtlCol="0" anchor="t" wrap="square" lIns="177800" rIns="177800" tIns="101600" bIns="127000">
+          <a:bodyPr rtlCol="0" anchor="t" wrap="square" lIns="177800" rIns="177800" tIns="18119" bIns="127000">
             <a:noAutofit/>
           </a:bodyPr>
           <a:lstStyle/>
@@ -15956,7 +15859,7 @@
         </p:nvSpPr>
         <p:spPr>
           <a:xfrm>
-            <a:off x="594360" y="2476119"/>
+            <a:off x="594360" y="2355936"/>
             <a:ext cx="7955279" cy="228600"/>
           </a:xfrm>
           <a:prstGeom prst="rect">
@@ -16010,7 +15913,7 @@
         </p:nvSpPr>
         <p:spPr>
           <a:xfrm>
-            <a:off x="594360" y="2777871"/>
+            <a:off x="594360" y="2657688"/>
             <a:ext cx="7955279" cy="378206"/>
           </a:xfrm>
           <a:prstGeom prst="rect">
@@ -16064,7 +15967,7 @@
         </p:nvSpPr>
         <p:spPr>
           <a:xfrm>
-            <a:off x="594360" y="3338957"/>
+            <a:off x="594360" y="3218774"/>
             <a:ext cx="7955279" cy="594360"/>
           </a:xfrm>
           <a:prstGeom prst="rect">
@@ -16159,22 +16062,8 @@
                 <a:ea typeface="Noto Sans CJK JP"/>
                 <a:cs typeface="Noto Sans"/>
               </a:rPr>
-              <a:t>[1] Stanford CRFM, HELM Classic v0.4.0, TwitterAAE. 公開実行suite v0.3.0。 instance: aa/id46250（HELM内ID）</a:t>
-            </a:r>
-          </a:p>
-          <a:p>
-            <a:pPr>
-              <a:lnSpc>
-                <a:spcPts val="940"/>
-              </a:lnSpc>
-              <a:buNone/>
-              <a:defRPr sz="810" b="0">
-                <a:solidFill>
-                  <a:srgbClr val="303437"/>
-                </a:solidFill>
-                <a:latin typeface="Noto Sans"/>
-              </a:defRPr>
-            </a:pPr>
+              <a:t>[1] Stanford CRFM. HELM Classic v0.4.0 — TwitterAAE.  </a:t>
+            </a:r>
             <a:r>
               <a:rPr sz="810" b="0" lang="ja-JP" altLang="en-US">
                 <a:solidFill>
@@ -16366,8 +16255,8 @@
         </p:nvSpPr>
         <p:spPr>
           <a:xfrm>
-            <a:off x="548640" y="1673352"/>
-            <a:ext cx="8046720" cy="601598"/>
+            <a:off x="548640" y="1756833"/>
+            <a:ext cx="8046720" cy="465667"/>
           </a:xfrm>
           <a:prstGeom prst="rect">
             <a:avLst/>
@@ -16395,7 +16284,7 @@
           </a:fontRef>
         </p:style>
         <p:txBody>
-          <a:bodyPr rtlCol="0" anchor="t" wrap="square" lIns="177800" rIns="177800" tIns="101600" bIns="127000">
+          <a:bodyPr rtlCol="0" anchor="t" wrap="square" lIns="177800" rIns="177800" tIns="18119" bIns="127000">
             <a:noAutofit/>
           </a:bodyPr>
           <a:lstStyle/>
@@ -16440,7 +16329,7 @@
         </p:nvSpPr>
         <p:spPr>
           <a:xfrm>
-            <a:off x="594360" y="2476119"/>
+            <a:off x="594360" y="2423670"/>
             <a:ext cx="7955279" cy="228600"/>
           </a:xfrm>
           <a:prstGeom prst="rect">
@@ -16494,7 +16383,7 @@
         </p:nvSpPr>
         <p:spPr>
           <a:xfrm>
-            <a:off x="594360" y="2777871"/>
+            <a:off x="594360" y="2725422"/>
             <a:ext cx="7955279" cy="378206"/>
           </a:xfrm>
           <a:prstGeom prst="rect">
@@ -16548,7 +16437,7 @@
         </p:nvSpPr>
         <p:spPr>
           <a:xfrm>
-            <a:off x="594360" y="3338957"/>
+            <a:off x="594360" y="3286508"/>
             <a:ext cx="7955279" cy="594360"/>
           </a:xfrm>
           <a:prstGeom prst="rect">
@@ -16589,7 +16478,7 @@
                 <a:ea typeface="Noto Sans CJK JP"/>
                 <a:cs typeface="Noto Sans"/>
               </a:rPr>
-              <a:t>ndはandに相当する。反復と感嘆符も表現の一部。</a:t>
+              <a:t>ndはandの略。writenの反復と感嘆符が、書き続ける調子を作る。</a:t>
             </a:r>
           </a:p>
         </p:txBody>
@@ -16643,22 +16532,8 @@
                 <a:ea typeface="Noto Sans CJK JP"/>
                 <a:cs typeface="Noto Sans"/>
               </a:rPr>
-              <a:t>[1] Stanford CRFM, HELM Classic v0.4.0, TwitterAAE. 公開実行suite v0.3.0。 instance: aa/id24647（HELM内ID）</a:t>
-            </a:r>
-          </a:p>
-          <a:p>
-            <a:pPr>
-              <a:lnSpc>
-                <a:spcPts val="940"/>
-              </a:lnSpc>
-              <a:buNone/>
-              <a:defRPr sz="810" b="0">
-                <a:solidFill>
-                  <a:srgbClr val="303437"/>
-                </a:solidFill>
-                <a:latin typeface="Noto Sans"/>
-              </a:defRPr>
-            </a:pPr>
+              <a:t>[1] Stanford CRFM. HELM Classic v0.4.0 — TwitterAAE.  </a:t>
+            </a:r>
             <a:r>
               <a:rPr sz="810" b="0" lang="ja-JP" altLang="en-US">
                 <a:solidFill>
@@ -16850,8 +16725,8 @@
         </p:nvSpPr>
         <p:spPr>
           <a:xfrm>
-            <a:off x="548640" y="1673352"/>
-            <a:ext cx="8046720" cy="601598"/>
+            <a:off x="548640" y="1756833"/>
+            <a:ext cx="8046720" cy="465667"/>
           </a:xfrm>
           <a:prstGeom prst="rect">
             <a:avLst/>
@@ -16879,7 +16754,7 @@
           </a:fontRef>
         </p:style>
         <p:txBody>
-          <a:bodyPr rtlCol="0" anchor="t" wrap="square" lIns="177800" rIns="177800" tIns="101600" bIns="127000">
+          <a:bodyPr rtlCol="0" anchor="t" wrap="square" lIns="177800" rIns="177800" tIns="18119" bIns="127000">
             <a:noAutofit/>
           </a:bodyPr>
           <a:lstStyle/>
@@ -16924,7 +16799,7 @@
         </p:nvSpPr>
         <p:spPr>
           <a:xfrm>
-            <a:off x="594360" y="2476119"/>
+            <a:off x="594360" y="2423670"/>
             <a:ext cx="7955279" cy="228600"/>
           </a:xfrm>
           <a:prstGeom prst="rect">
@@ -16978,7 +16853,7 @@
         </p:nvSpPr>
         <p:spPr>
           <a:xfrm>
-            <a:off x="594360" y="2777871"/>
+            <a:off x="594360" y="2725422"/>
             <a:ext cx="7955279" cy="378206"/>
           </a:xfrm>
           <a:prstGeom prst="rect">
@@ -17032,7 +16907,7 @@
         </p:nvSpPr>
         <p:spPr>
           <a:xfrm>
-            <a:off x="594360" y="3338957"/>
+            <a:off x="594360" y="3286508"/>
             <a:ext cx="7955279" cy="594360"/>
           </a:xfrm>
           <a:prstGeom prst="rect">
@@ -17127,22 +17002,8 @@
                 <a:ea typeface="Noto Sans CJK JP"/>
                 <a:cs typeface="Noto Sans"/>
               </a:rPr>
-              <a:t>[1] Stanford CRFM, HELM Classic v0.4.0, TwitterAAE. 公開実行suite v0.3.0。 instance: aa/id29079（HELM内ID）</a:t>
-            </a:r>
-          </a:p>
-          <a:p>
-            <a:pPr>
-              <a:lnSpc>
-                <a:spcPts val="940"/>
-              </a:lnSpc>
-              <a:buNone/>
-              <a:defRPr sz="810" b="0">
-                <a:solidFill>
-                  <a:srgbClr val="303437"/>
-                </a:solidFill>
-                <a:latin typeface="Noto Sans"/>
-              </a:defRPr>
-            </a:pPr>
+              <a:t>[1] Stanford CRFM. HELM Classic v0.4.0 — TwitterAAE.  </a:t>
+            </a:r>
             <a:r>
               <a:rPr sz="810" b="0" lang="ja-JP" altLang="en-US">
                 <a:solidFill>
@@ -17334,8 +17195,8 @@
         </p:nvSpPr>
         <p:spPr>
           <a:xfrm>
-            <a:off x="548640" y="1673352"/>
-            <a:ext cx="8046720" cy="601598"/>
+            <a:off x="548640" y="1756833"/>
+            <a:ext cx="8046720" cy="397934"/>
           </a:xfrm>
           <a:prstGeom prst="rect">
             <a:avLst/>
@@ -17363,7 +17224,7 @@
           </a:fontRef>
         </p:style>
         <p:txBody>
-          <a:bodyPr rtlCol="0" anchor="t" wrap="square" lIns="177800" rIns="177800" tIns="101600" bIns="127000">
+          <a:bodyPr rtlCol="0" anchor="t" wrap="square" lIns="177800" rIns="177800" tIns="18119" bIns="127000">
             <a:noAutofit/>
           </a:bodyPr>
           <a:lstStyle/>
@@ -17408,7 +17269,7 @@
         </p:nvSpPr>
         <p:spPr>
           <a:xfrm>
-            <a:off x="594360" y="2476119"/>
+            <a:off x="594360" y="2355936"/>
             <a:ext cx="7955279" cy="228600"/>
           </a:xfrm>
           <a:prstGeom prst="rect">
@@ -17462,7 +17323,7 @@
         </p:nvSpPr>
         <p:spPr>
           <a:xfrm>
-            <a:off x="594360" y="2777871"/>
+            <a:off x="594360" y="2657688"/>
             <a:ext cx="7955279" cy="378206"/>
           </a:xfrm>
           <a:prstGeom prst="rect">
@@ -17516,7 +17377,7 @@
         </p:nvSpPr>
         <p:spPr>
           <a:xfrm>
-            <a:off x="594360" y="3338957"/>
+            <a:off x="594360" y="3218774"/>
             <a:ext cx="7955279" cy="594360"/>
           </a:xfrm>
           <a:prstGeom prst="rect">
@@ -17611,22 +17472,8 @@
                 <a:ea typeface="Noto Sans CJK JP"/>
                 <a:cs typeface="Noto Sans"/>
               </a:rPr>
-              <a:t>[1] Stanford CRFM, HELM Classic v0.4.0, TwitterAAE. 公開実行suite v0.3.0。 instance: white/id32104（HELM内ID）</a:t>
-            </a:r>
-          </a:p>
-          <a:p>
-            <a:pPr>
-              <a:lnSpc>
-                <a:spcPts val="940"/>
-              </a:lnSpc>
-              <a:buNone/>
-              <a:defRPr sz="810" b="0">
-                <a:solidFill>
-                  <a:srgbClr val="303437"/>
-                </a:solidFill>
-                <a:latin typeface="Noto Sans"/>
-              </a:defRPr>
-            </a:pPr>
+              <a:t>[1] Stanford CRFM. HELM Classic v0.4.0 — TwitterAAE.  </a:t>
+            </a:r>
             <a:r>
               <a:rPr sz="810" b="0" lang="ja-JP" altLang="en-US">
                 <a:solidFill>
@@ -17818,8 +17665,8 @@
         </p:nvSpPr>
         <p:spPr>
           <a:xfrm>
-            <a:off x="548640" y="1673352"/>
-            <a:ext cx="8046720" cy="601598"/>
+            <a:off x="548640" y="1756833"/>
+            <a:ext cx="8046720" cy="465667"/>
           </a:xfrm>
           <a:prstGeom prst="rect">
             <a:avLst/>
@@ -17847,7 +17694,7 @@
           </a:fontRef>
         </p:style>
         <p:txBody>
-          <a:bodyPr rtlCol="0" anchor="t" wrap="square" lIns="177800" rIns="177800" tIns="101600" bIns="127000">
+          <a:bodyPr rtlCol="0" anchor="t" wrap="square" lIns="177800" rIns="177800" tIns="18119" bIns="127000">
             <a:noAutofit/>
           </a:bodyPr>
           <a:lstStyle/>
@@ -17892,7 +17739,7 @@
         </p:nvSpPr>
         <p:spPr>
           <a:xfrm>
-            <a:off x="594360" y="2476119"/>
+            <a:off x="594360" y="2423670"/>
             <a:ext cx="7955279" cy="228600"/>
           </a:xfrm>
           <a:prstGeom prst="rect">
@@ -17946,7 +17793,7 @@
         </p:nvSpPr>
         <p:spPr>
           <a:xfrm>
-            <a:off x="594360" y="2777871"/>
+            <a:off x="594360" y="2725422"/>
             <a:ext cx="7955279" cy="378206"/>
           </a:xfrm>
           <a:prstGeom prst="rect">
@@ -18000,7 +17847,7 @@
         </p:nvSpPr>
         <p:spPr>
           <a:xfrm>
-            <a:off x="594360" y="3338957"/>
+            <a:off x="594360" y="3286508"/>
             <a:ext cx="7955279" cy="594360"/>
           </a:xfrm>
           <a:prstGeom prst="rect">
@@ -18095,22 +17942,8 @@
                 <a:ea typeface="Noto Sans CJK JP"/>
                 <a:cs typeface="Noto Sans"/>
               </a:rPr>
-              <a:t>[1] Stanford CRFM, HELM Classic v0.4.0, TwitterAAE. 公開実行suite v0.3.0。 instance: white/id46712（HELM内ID）</a:t>
-            </a:r>
-          </a:p>
-          <a:p>
-            <a:pPr>
-              <a:lnSpc>
-                <a:spcPts val="940"/>
-              </a:lnSpc>
-              <a:buNone/>
-              <a:defRPr sz="810" b="0">
-                <a:solidFill>
-                  <a:srgbClr val="303437"/>
-                </a:solidFill>
-                <a:latin typeface="Noto Sans"/>
-              </a:defRPr>
-            </a:pPr>
+              <a:t>[1] Stanford CRFM. HELM Classic v0.4.0 — TwitterAAE.  </a:t>
+            </a:r>
             <a:r>
               <a:rPr sz="810" b="0" lang="ja-JP" altLang="en-US">
                 <a:solidFill>
@@ -18302,8 +18135,8 @@
         </p:nvSpPr>
         <p:spPr>
           <a:xfrm>
-            <a:off x="548640" y="1673352"/>
-            <a:ext cx="8046720" cy="601598"/>
+            <a:off x="548640" y="1756833"/>
+            <a:ext cx="8046720" cy="465667"/>
           </a:xfrm>
           <a:prstGeom prst="rect">
             <a:avLst/>
@@ -18331,7 +18164,7 @@
           </a:fontRef>
         </p:style>
         <p:txBody>
-          <a:bodyPr rtlCol="0" anchor="t" wrap="square" lIns="177800" rIns="177800" tIns="101600" bIns="127000">
+          <a:bodyPr rtlCol="0" anchor="t" wrap="square" lIns="177800" rIns="177800" tIns="18119" bIns="127000">
             <a:noAutofit/>
           </a:bodyPr>
           <a:lstStyle/>
@@ -18376,7 +18209,7 @@
         </p:nvSpPr>
         <p:spPr>
           <a:xfrm>
-            <a:off x="594360" y="2476119"/>
+            <a:off x="594360" y="2423670"/>
             <a:ext cx="7955279" cy="228600"/>
           </a:xfrm>
           <a:prstGeom prst="rect">
@@ -18430,7 +18263,7 @@
         </p:nvSpPr>
         <p:spPr>
           <a:xfrm>
-            <a:off x="594360" y="2777871"/>
+            <a:off x="594360" y="2725422"/>
             <a:ext cx="7955279" cy="378206"/>
           </a:xfrm>
           <a:prstGeom prst="rect">
@@ -18484,7 +18317,7 @@
         </p:nvSpPr>
         <p:spPr>
           <a:xfrm>
-            <a:off x="594360" y="3338957"/>
+            <a:off x="594360" y="3286508"/>
             <a:ext cx="7955279" cy="594360"/>
           </a:xfrm>
           <a:prstGeom prst="rect">
@@ -18525,7 +18358,7 @@
                 <a:ea typeface="Noto Sans CJK JP"/>
                 <a:cs typeface="Noto Sans"/>
               </a:rPr>
-              <a:t>thisの指す内容は公開された一文からは特定できない。</a:t>
+              <a:t>thisの具体的な内容は省かれ、続けることへの迷いを短く伝える。</a:t>
             </a:r>
           </a:p>
         </p:txBody>
@@ -18579,22 +18412,8 @@
                 <a:ea typeface="Noto Sans CJK JP"/>
                 <a:cs typeface="Noto Sans"/>
               </a:rPr>
-              <a:t>[1] Stanford CRFM, HELM Classic v0.4.0, TwitterAAE. 公開実行suite v0.3.0。 instance: white/id42460（HELM内ID）</a:t>
-            </a:r>
-          </a:p>
-          <a:p>
-            <a:pPr>
-              <a:lnSpc>
-                <a:spcPts val="940"/>
-              </a:lnSpc>
-              <a:buNone/>
-              <a:defRPr sz="810" b="0">
-                <a:solidFill>
-                  <a:srgbClr val="303437"/>
-                </a:solidFill>
-                <a:latin typeface="Noto Sans"/>
-              </a:defRPr>
-            </a:pPr>
+              <a:t>[1] Stanford CRFM. HELM Classic v0.4.0 — TwitterAAE.  </a:t>
+            </a:r>
             <a:r>
               <a:rPr sz="810" b="0" lang="ja-JP" altLang="en-US">
                 <a:solidFill>
@@ -18786,8 +18605,8 @@
         </p:nvSpPr>
         <p:spPr>
           <a:xfrm>
-            <a:off x="548640" y="1673352"/>
-            <a:ext cx="8046720" cy="601598"/>
+            <a:off x="548640" y="1773766"/>
+            <a:ext cx="8046720" cy="381000"/>
           </a:xfrm>
           <a:prstGeom prst="rect">
             <a:avLst/>
@@ -18815,7 +18634,7 @@
           </a:fontRef>
         </p:style>
         <p:txBody>
-          <a:bodyPr rtlCol="0" anchor="t" wrap="square" lIns="177800" rIns="177800" tIns="101600" bIns="127000">
+          <a:bodyPr rtlCol="0" anchor="t" wrap="square" lIns="177800" rIns="177800" tIns="1186" bIns="127000">
             <a:noAutofit/>
           </a:bodyPr>
           <a:lstStyle/>
@@ -18860,7 +18679,7 @@
         </p:nvSpPr>
         <p:spPr>
           <a:xfrm>
-            <a:off x="594360" y="2476119"/>
+            <a:off x="594360" y="2355936"/>
             <a:ext cx="7955279" cy="228600"/>
           </a:xfrm>
           <a:prstGeom prst="rect">
@@ -18914,7 +18733,7 @@
         </p:nvSpPr>
         <p:spPr>
           <a:xfrm>
-            <a:off x="594360" y="2777871"/>
+            <a:off x="594360" y="2657688"/>
             <a:ext cx="7955279" cy="378206"/>
           </a:xfrm>
           <a:prstGeom prst="rect">
@@ -18968,7 +18787,7 @@
         </p:nvSpPr>
         <p:spPr>
           <a:xfrm>
-            <a:off x="594360" y="3338957"/>
+            <a:off x="594360" y="3218774"/>
             <a:ext cx="7955279" cy="594360"/>
           </a:xfrm>
           <a:prstGeom prst="rect">
@@ -19009,7 +18828,7 @@
                 <a:ea typeface="Noto Sans CJK JP"/>
                 <a:cs typeface="Noto Sans"/>
               </a:rPr>
-              <a:t>I cannot even.は文脈に依存する口語表現として訳した。</a:t>
+              <a:t>I cannot even.は、驚きやあきれなどで言葉が続かないことを表す口語表現。</a:t>
             </a:r>
           </a:p>
         </p:txBody>
@@ -19063,22 +18882,8 @@
                 <a:ea typeface="Noto Sans CJK JP"/>
                 <a:cs typeface="Noto Sans"/>
               </a:rPr>
-              <a:t>[1] Stanford CRFM, HELM Classic v0.4.0, TwitterAAE. 公開実行suite v0.3.0。 instance: white/id19412（HELM内ID）</a:t>
-            </a:r>
-          </a:p>
-          <a:p>
-            <a:pPr>
-              <a:lnSpc>
-                <a:spcPts val="940"/>
-              </a:lnSpc>
-              <a:buNone/>
-              <a:defRPr sz="810" b="0">
-                <a:solidFill>
-                  <a:srgbClr val="303437"/>
-                </a:solidFill>
-                <a:latin typeface="Noto Sans"/>
-              </a:defRPr>
-            </a:pPr>
+              <a:t>[1] Stanford CRFM. HELM Classic v0.4.0 — TwitterAAE.  </a:t>
+            </a:r>
             <a:r>
               <a:rPr sz="810" b="0" lang="ja-JP" altLang="en-US">
                 <a:solidFill>
@@ -19270,8 +19075,8 @@
         </p:nvSpPr>
         <p:spPr>
           <a:xfrm>
-            <a:off x="548640" y="1673352"/>
-            <a:ext cx="8046720" cy="601598"/>
+            <a:off x="548640" y="1756833"/>
+            <a:ext cx="8046720" cy="465667"/>
           </a:xfrm>
           <a:prstGeom prst="rect">
             <a:avLst/>
@@ -19299,7 +19104,7 @@
           </a:fontRef>
         </p:style>
         <p:txBody>
-          <a:bodyPr rtlCol="0" anchor="t" wrap="square" lIns="177800" rIns="177800" tIns="101600" bIns="127000">
+          <a:bodyPr rtlCol="0" anchor="t" wrap="square" lIns="177800" rIns="177800" tIns="18119" bIns="127000">
             <a:noAutofit/>
           </a:bodyPr>
           <a:lstStyle/>
@@ -19344,7 +19149,7 @@
         </p:nvSpPr>
         <p:spPr>
           <a:xfrm>
-            <a:off x="594360" y="2476119"/>
+            <a:off x="594360" y="2423670"/>
             <a:ext cx="7955279" cy="228600"/>
           </a:xfrm>
           <a:prstGeom prst="rect">
@@ -19398,7 +19203,7 @@
         </p:nvSpPr>
         <p:spPr>
           <a:xfrm>
-            <a:off x="594360" y="2777871"/>
+            <a:off x="594360" y="2725422"/>
             <a:ext cx="7955279" cy="710692"/>
           </a:xfrm>
           <a:prstGeom prst="rect">
@@ -19452,7 +19257,7 @@
         </p:nvSpPr>
         <p:spPr>
           <a:xfrm>
-            <a:off x="594360" y="3671443"/>
+            <a:off x="594360" y="3618994"/>
             <a:ext cx="7955279" cy="594360"/>
           </a:xfrm>
           <a:prstGeom prst="rect">
@@ -19493,7 +19298,7 @@
                 <a:ea typeface="Noto Sans CJK JP"/>
                 <a:cs typeface="Noto Sans"/>
               </a:rPr>
-              <a:t>時間の数値と疑問の調子を保った。</a:t>
+              <a:t>3時間という長さと、まだ疲れているという疑問を一息に伝える。</a:t>
             </a:r>
           </a:p>
         </p:txBody>
@@ -19547,22 +19352,8 @@
                 <a:ea typeface="Noto Sans CJK JP"/>
                 <a:cs typeface="Noto Sans"/>
               </a:rPr>
-              <a:t>[1] Stanford CRFM, HELM Classic v0.4.0, TwitterAAE. 公開実行suite v0.3.0。 instance: white/id5140（HELM内ID）</a:t>
-            </a:r>
-          </a:p>
-          <a:p>
-            <a:pPr>
-              <a:lnSpc>
-                <a:spcPts val="940"/>
-              </a:lnSpc>
-              <a:buNone/>
-              <a:defRPr sz="810" b="0">
-                <a:solidFill>
-                  <a:srgbClr val="303437"/>
-                </a:solidFill>
-                <a:latin typeface="Noto Sans"/>
-              </a:defRPr>
-            </a:pPr>
+              <a:t>[1] Stanford CRFM. HELM Classic v0.4.0 — TwitterAAE.  </a:t>
+            </a:r>
             <a:r>
               <a:rPr sz="810" b="0" lang="ja-JP" altLang="en-US">
                 <a:solidFill>
@@ -19639,7 +19430,7 @@
                 <a:ea typeface="Noto Sans CJK JP"/>
                 <a:cs typeface="Noto Sans"/>
               </a:rPr>
-              <a:t>版・実行条件の補足</a:t>
+              <a:t>入力と指標の補足</a:t>
             </a:r>
           </a:p>
         </p:txBody>
@@ -19687,7 +19478,7 @@
                 <a:ea typeface="Noto Sans CJK JP"/>
                 <a:cs typeface="Noto Sans"/>
               </a:rPr>
-              <a:t>Appendix: 2. 版・実行条件の補足</a:t>
+              <a:t>Appendix: 2. 入力と指標の補足</a:t>
             </a:r>
           </a:p>
         </p:txBody>
@@ -19867,7 +19658,7 @@
                 <a:ea typeface="Noto Sans CJK JP"/>
                 <a:cs typeface="Noto Sans"/>
               </a:rPr>
-              <a:t>公開実行入力の長さを確かめた</a:t>
+              <a:t>HELMの投稿は、AA側が平均約40文字</a:t>
             </a:r>
           </a:p>
         </p:txBody>
@@ -19915,7 +19706,7 @@
                 <a:ea typeface="Noto Sans CJK JP"/>
                 <a:cs typeface="Noto Sans"/>
               </a:rPr>
-              <a:t>Appendix: 2. 版・実行条件の補足</a:t>
+              <a:t>Appendix: 2. 入力と指標の補足</a:t>
             </a:r>
           </a:p>
         </p:txBody>
@@ -20638,7 +20429,7 @@
                 <a:ea typeface="Noto Sans CJK JP"/>
                 <a:cs typeface="Noto Sans"/>
               </a:rPr>
-              <a:t>Unicodeコードポイント数。エスケープ文字列は入力のまま数えた。元の2013年ツイート表示上の文字数ではない。</a:t>
+              <a:t>HELMで使われた各1,000投稿の文字数。Unicodeの文字単位で、エスケープ表現も入力のつづりどおり数えた。</a:t>
             </a:r>
           </a:p>
         </p:txBody>
@@ -20692,18 +20483,7 @@
                 <a:ea typeface="Noto Sans CJK JP"/>
                 <a:cs typeface="Noto Sans"/>
               </a:rPr>
-              <a:t>[1] Stanford CRFM, HELM Classic v0.4.0, TwitterAAE. 公開実行suite v0.3.0。</a:t>
-            </a:r>
-            <a:r>
-              <a:rPr sz="810" b="0" lang="ja-JP" altLang="en-US">
-                <a:solidFill>
-                  <a:srgbClr val="626669"/>
-                </a:solidFill>
-                <a:latin typeface="Noto Sans"/>
-                <a:ea typeface="Noto Sans CJK JP"/>
-                <a:cs typeface="Noto Sans"/>
-              </a:rPr>
-              <a:t>  </a:t>
+              <a:t>[1] Stanford CRFM. HELM Classic v0.4.0 — TwitterAAE.  </a:t>
             </a:r>
             <a:r>
               <a:rPr sz="810" b="0" lang="ja-JP" altLang="en-US">
@@ -20781,7 +20561,7 @@
                 <a:ea typeface="Noto Sans CJK JP"/>
                 <a:cs typeface="Noto Sans"/>
               </a:rPr>
-              <a:t>文字の表現も、評価入力の一部になる</a:t>
+              <a:t>絵文字のエスケープ表現も入力に含む</a:t>
             </a:r>
           </a:p>
         </p:txBody>
@@ -20829,7 +20609,7 @@
                 <a:ea typeface="Noto Sans CJK JP"/>
                 <a:cs typeface="Noto Sans"/>
               </a:rPr>
-              <a:t>Appendix: 2. 版・実行条件の補足</a:t>
+              <a:t>Appendix: 2. 入力と指標の補足</a:t>
             </a:r>
           </a:p>
         </p:txBody>
@@ -20883,7 +20663,7 @@
                 <a:ea typeface="Noto Sans CJK JP"/>
                 <a:cs typeface="Noto Sans"/>
               </a:rPr>
-              <a:t>公開入力には、絵文字を文字列のまま表した「\ud83d\ude02」のようなエスケープ表現もある。</a:t>
+              <a:t>HELMの入力には、絵文字を「\ud83d\ude02」のようなエスケープ表現にした投稿もある。</a:t>
             </a:r>
           </a:p>
         </p:txBody>
@@ -20937,21 +20717,21 @@
                 <a:ea typeface="Noto Sans CJK JP"/>
                 <a:cs typeface="Noto Sans"/>
               </a:rPr>
-              <a:t>本資料の実例はそれらを復号・訂正せず、公開実行で使われたinput.textを保存する。短い自然文だけを選び、本文の実例で表記を追いやすくした。</a:t>
-            </a:r>
-          </a:p>
-        </p:txBody>
-      </p:sp>
-      <p:sp>
-        <p:nvSpPr>
-          <p:cNvPr id="6" name="TextBox 5"/>
+              <a:t>モデルは、この表現を含む文字列に確率を付ける。画面で絵文字として表示した場合とは、入力の長さやトークンの分割が変わる。</a:t>
+            </a:r>
+          </a:p>
+        </p:txBody>
+      </p:sp>
+      <p:sp>
+        <p:nvSpPr>
+          <p:cNvPr id="7" name="sources"/>
           <p:cNvSpPr txBox="1"/>
           <p:nvPr/>
         </p:nvSpPr>
         <p:spPr>
           <a:xfrm>
-            <a:off x="594360" y="3470529"/>
-            <a:ext cx="7955279" cy="680466"/>
+            <a:off x="502920" y="4700016"/>
+            <a:ext cx="8183879" cy="530352"/>
           </a:xfrm>
           <a:prstGeom prst="rect">
             <a:avLst/>
@@ -20966,60 +20746,6 @@
           <a:p>
             <a:pPr algn="l">
               <a:lnSpc>
-                <a:spcPts val="2499"/>
-              </a:lnSpc>
-              <a:spcBef>
-                <a:spcPts val="0"/>
-              </a:spcBef>
-              <a:spcAft>
-                <a:spcPts val="0"/>
-              </a:spcAft>
-              <a:buNone/>
-              <a:defRPr sz="2100" b="0">
-                <a:solidFill>
-                  <a:srgbClr val="303437"/>
-                </a:solidFill>
-                <a:latin typeface="Noto Sans"/>
-              </a:defRPr>
-            </a:pPr>
-            <a:r>
-              <a:rPr sz="2100" b="0" lang="ja-JP" altLang="en-US">
-                <a:solidFill>
-                  <a:srgbClr val="303437"/>
-                </a:solidFill>
-                <a:latin typeface="Noto Sans"/>
-                <a:ea typeface="Noto Sans CJK JP"/>
-                <a:cs typeface="Noto Sans"/>
-              </a:rPr>
-              <a:t>HELM内のid11841などは投稿のTwitter IDではなく、条件内のインスタンスID。同じ番号でもAAとwhiteで本文が異なる。</a:t>
-            </a:r>
-          </a:p>
-        </p:txBody>
-      </p:sp>
-      <p:sp>
-        <p:nvSpPr>
-          <p:cNvPr id="7" name="sources"/>
-          <p:cNvSpPr txBox="1"/>
-          <p:nvPr/>
-        </p:nvSpPr>
-        <p:spPr>
-          <a:xfrm>
-            <a:off x="502920" y="4700016"/>
-            <a:ext cx="8183879" cy="530352"/>
-          </a:xfrm>
-          <a:prstGeom prst="rect">
-            <a:avLst/>
-          </a:prstGeom>
-          <a:noFill/>
-        </p:spPr>
-        <p:txBody>
-          <a:bodyPr wrap="square" lIns="0" rIns="0" tIns="0" bIns="0">
-            <a:noAutofit/>
-          </a:bodyPr>
-          <a:lstStyle/>
-          <a:p>
-            <a:pPr algn="l">
-              <a:lnSpc>
                 <a:spcPts val="940"/>
               </a:lnSpc>
               <a:spcBef>
@@ -21045,18 +20771,7 @@
                 <a:ea typeface="Noto Sans CJK JP"/>
                 <a:cs typeface="Noto Sans"/>
               </a:rPr>
-              <a:t>[1] Stanford CRFM, HELM Classic v0.4.0, TwitterAAE. 公開実行suite v0.3.0。</a:t>
-            </a:r>
-            <a:r>
-              <a:rPr sz="810" b="0" lang="ja-JP" altLang="en-US">
-                <a:solidFill>
-                  <a:srgbClr val="626669"/>
-                </a:solidFill>
-                <a:latin typeface="Noto Sans"/>
-                <a:ea typeface="Noto Sans CJK JP"/>
-                <a:cs typeface="Noto Sans"/>
-              </a:rPr>
-              <a:t>  </a:t>
+              <a:t>[1] Stanford CRFM. HELM Classic v0.4.0 — TwitterAAE.  </a:t>
             </a:r>
             <a:r>
               <a:rPr sz="810" b="0" lang="ja-JP" altLang="en-US">
@@ -21134,7 +20849,7 @@
                 <a:ea typeface="Noto Sans CJK JP"/>
                 <a:cs typeface="Noto Sans"/>
               </a:rPr>
-              <a:t>公開実行の設定は両モデルで共通</a:t>
+              <a:t>公開実行のJSONから、投稿全文を読み出す</a:t>
             </a:r>
           </a:p>
         </p:txBody>
@@ -21182,671 +20897,11 @@
                 <a:ea typeface="Noto Sans CJK JP"/>
                 <a:cs typeface="Noto Sans"/>
               </a:rPr>
-              <a:t>Appendix: 2. 版・実行条件の補足</a:t>
-            </a:r>
-          </a:p>
-        </p:txBody>
-      </p:sp>
-      <p:graphicFrame>
-        <p:nvGraphicFramePr>
-          <p:cNvPr id="4" name="Table 3"/>
-          <p:cNvGraphicFramePr>
-            <a:graphicFrameLocks noGrp="1"/>
-          </p:cNvGraphicFramePr>
-          <p:nvPr/>
-        </p:nvGraphicFramePr>
-        <p:xfrm>
-          <a:off x="548640" y="1508760"/>
-          <a:ext cx="8046720" cy="2523744"/>
-        </p:xfrm>
-        <a:graphic>
-          <a:graphicData uri="http://schemas.openxmlformats.org/drawingml/2006/table">
-            <a:tbl>
-              <a:tblPr firstRow="0" bandRow="0"/>
-              <a:tblGrid>
-                <a:gridCol w="4937760"/>
-                <a:gridCol w="3108960"/>
-              </a:tblGrid>
-              <a:tr h="420624">
-                <a:tc>
-                  <a:txBody>
-                    <a:bodyPr wrap="square">
-                      <a:noAutofit/>
-                    </a:bodyPr>
-                    <a:lstStyle/>
-                    <a:p>
-                      <a:pPr algn="l">
-                        <a:lnSpc>
-                          <a:spcPts val="2127"/>
-                        </a:lnSpc>
-                        <a:buNone/>
-                        <a:defRPr sz="1850" b="0">
-                          <a:solidFill>
-                            <a:srgbClr val="303437"/>
-                          </a:solidFill>
-                          <a:latin typeface="Noto Sans"/>
-                        </a:defRPr>
-                      </a:pPr>
-                      <a:r>
-                        <a:rPr sz="1850" b="0" lang="ja-JP" altLang="en-US">
-                          <a:solidFill>
-                            <a:srgbClr val="303437"/>
-                          </a:solidFill>
-                          <a:latin typeface="Noto Sans"/>
-                          <a:ea typeface="Noto Sans CJK JP"/>
-                          <a:cs typeface="Noto Sans"/>
-                        </a:rPr>
-                        <a:t>設定</a:t>
-                      </a:r>
-                    </a:p>
-                  </a:txBody>
-                  <a:tcPr marL="63500" marR="63500" marT="38100" marB="38100" anchor="ctr">
-                    <a:lnL w="7620">
-                      <a:noFill/>
-                    </a:lnL>
-                    <a:lnR w="7620">
-                      <a:noFill/>
-                    </a:lnR>
-                    <a:lnT w="15240">
-                      <a:solidFill>
-                        <a:srgbClr val="626669"/>
-                      </a:solidFill>
-                      <a:prstDash val="solid"/>
-                    </a:lnT>
-                    <a:lnB w="7620">
-                      <a:solidFill>
-                        <a:srgbClr val="626669"/>
-                      </a:solidFill>
-                      <a:prstDash val="solid"/>
-                    </a:lnB>
-                    <a:solidFill>
-                      <a:srgbClr val="FFFEF8"/>
-                    </a:solidFill>
-                  </a:tcPr>
-                </a:tc>
-                <a:tc>
-                  <a:txBody>
-                    <a:bodyPr wrap="square">
-                      <a:noAutofit/>
-                    </a:bodyPr>
-                    <a:lstStyle/>
-                    <a:p>
-                      <a:pPr algn="l">
-                        <a:lnSpc>
-                          <a:spcPts val="2127"/>
-                        </a:lnSpc>
-                        <a:buNone/>
-                        <a:defRPr sz="1850" b="0">
-                          <a:solidFill>
-                            <a:srgbClr val="303437"/>
-                          </a:solidFill>
-                          <a:latin typeface="Noto Sans"/>
-                        </a:defRPr>
-                      </a:pPr>
-                      <a:r>
-                        <a:rPr sz="1850" b="0" lang="ja-JP" altLang="en-US">
-                          <a:solidFill>
-                            <a:srgbClr val="303437"/>
-                          </a:solidFill>
-                          <a:latin typeface="Noto Sans"/>
-                          <a:ea typeface="Noto Sans CJK JP"/>
-                          <a:cs typeface="Noto Sans"/>
-                        </a:rPr>
-                        <a:t>値</a:t>
-                      </a:r>
-                    </a:p>
-                  </a:txBody>
-                  <a:tcPr marL="63500" marR="63500" marT="38100" marB="38100" anchor="ctr">
-                    <a:lnL w="7620">
-                      <a:noFill/>
-                    </a:lnL>
-                    <a:lnR w="7620">
-                      <a:noFill/>
-                    </a:lnR>
-                    <a:lnT w="15240">
-                      <a:solidFill>
-                        <a:srgbClr val="626669"/>
-                      </a:solidFill>
-                      <a:prstDash val="solid"/>
-                    </a:lnT>
-                    <a:lnB w="7620">
-                      <a:solidFill>
-                        <a:srgbClr val="626669"/>
-                      </a:solidFill>
-                      <a:prstDash val="solid"/>
-                    </a:lnB>
-                    <a:solidFill>
-                      <a:srgbClr val="FFFEF8"/>
-                    </a:solidFill>
-                  </a:tcPr>
-                </a:tc>
-              </a:tr>
-              <a:tr h="420624">
-                <a:tc>
-                  <a:txBody>
-                    <a:bodyPr wrap="square">
-                      <a:noAutofit/>
-                    </a:bodyPr>
-                    <a:lstStyle/>
-                    <a:p>
-                      <a:pPr algn="l">
-                        <a:lnSpc>
-                          <a:spcPts val="2127"/>
-                        </a:lnSpc>
-                        <a:buNone/>
-                        <a:defRPr sz="1850" b="0">
-                          <a:solidFill>
-                            <a:srgbClr val="303437"/>
-                          </a:solidFill>
-                          <a:latin typeface="Noto Sans"/>
-                        </a:defRPr>
-                      </a:pPr>
-                      <a:r>
-                        <a:rPr sz="1850" b="0" lang="ja-JP" altLang="en-US">
-                          <a:solidFill>
-                            <a:srgbClr val="303437"/>
-                          </a:solidFill>
-                          <a:latin typeface="Noto Sans"/>
-                          <a:ea typeface="Noto Sans CJK JP"/>
-                          <a:cs typeface="Noto Sans"/>
-                        </a:rPr>
-                        <a:t>method</a:t>
-                      </a:r>
-                    </a:p>
-                  </a:txBody>
-                  <a:tcPr marL="63500" marR="63500" marT="38100" marB="38100" anchor="ctr">
-                    <a:lnL w="7620">
-                      <a:noFill/>
-                    </a:lnL>
-                    <a:lnR w="7620">
-                      <a:noFill/>
-                    </a:lnR>
-                    <a:lnT w="7620">
-                      <a:solidFill>
-                        <a:srgbClr val="626669"/>
-                      </a:solidFill>
-                      <a:prstDash val="solid"/>
-                    </a:lnT>
-                    <a:lnB w="7620">
-                      <a:noFill/>
-                    </a:lnB>
-                    <a:solidFill>
-                      <a:srgbClr val="FFFEF8"/>
-                    </a:solidFill>
-                  </a:tcPr>
-                </a:tc>
-                <a:tc>
-                  <a:txBody>
-                    <a:bodyPr wrap="square">
-                      <a:noAutofit/>
-                    </a:bodyPr>
-                    <a:lstStyle/>
-                    <a:p>
-                      <a:pPr algn="l">
-                        <a:lnSpc>
-                          <a:spcPts val="2127"/>
-                        </a:lnSpc>
-                        <a:buNone/>
-                        <a:defRPr sz="1850" b="0">
-                          <a:solidFill>
-                            <a:srgbClr val="303437"/>
-                          </a:solidFill>
-                          <a:latin typeface="Noto Sans"/>
-                        </a:defRPr>
-                      </a:pPr>
-                      <a:r>
-                        <a:rPr sz="1850" b="0" lang="ja-JP" altLang="en-US">
-                          <a:solidFill>
-                            <a:srgbClr val="303437"/>
-                          </a:solidFill>
-                          <a:latin typeface="Noto Sans"/>
-                          <a:ea typeface="Noto Sans CJK JP"/>
-                          <a:cs typeface="Noto Sans"/>
-                        </a:rPr>
-                        <a:t>language_modeling</a:t>
-                      </a:r>
-                    </a:p>
-                  </a:txBody>
-                  <a:tcPr marL="63500" marR="63500" marT="38100" marB="38100" anchor="ctr">
-                    <a:lnL w="7620">
-                      <a:noFill/>
-                    </a:lnL>
-                    <a:lnR w="7620">
-                      <a:noFill/>
-                    </a:lnR>
-                    <a:lnT w="7620">
-                      <a:solidFill>
-                        <a:srgbClr val="626669"/>
-                      </a:solidFill>
-                      <a:prstDash val="solid"/>
-                    </a:lnT>
-                    <a:lnB w="7620">
-                      <a:noFill/>
-                    </a:lnB>
-                    <a:solidFill>
-                      <a:srgbClr val="FFFEF8"/>
-                    </a:solidFill>
-                  </a:tcPr>
-                </a:tc>
-              </a:tr>
-              <a:tr h="420624">
-                <a:tc>
-                  <a:txBody>
-                    <a:bodyPr wrap="square">
-                      <a:noAutofit/>
-                    </a:bodyPr>
-                    <a:lstStyle/>
-                    <a:p>
-                      <a:pPr algn="l">
-                        <a:lnSpc>
-                          <a:spcPts val="2127"/>
-                        </a:lnSpc>
-                        <a:buNone/>
-                        <a:defRPr sz="1850" b="0">
-                          <a:solidFill>
-                            <a:srgbClr val="303437"/>
-                          </a:solidFill>
-                          <a:latin typeface="Noto Sans"/>
-                        </a:defRPr>
-                      </a:pPr>
-                      <a:r>
-                        <a:rPr sz="1850" b="0" lang="ja-JP" altLang="en-US">
-                          <a:solidFill>
-                            <a:srgbClr val="303437"/>
-                          </a:solidFill>
-                          <a:latin typeface="Noto Sans"/>
-                          <a:ea typeface="Noto Sans CJK JP"/>
-                          <a:cs typeface="Noto Sans"/>
-                        </a:rPr>
-                        <a:t>max_eval_instances</a:t>
-                      </a:r>
-                    </a:p>
-                  </a:txBody>
-                  <a:tcPr marL="63500" marR="63500" marT="38100" marB="38100" anchor="ctr">
-                    <a:lnL w="7620">
-                      <a:noFill/>
-                    </a:lnL>
-                    <a:lnR w="7620">
-                      <a:noFill/>
-                    </a:lnR>
-                    <a:lnT w="7620">
-                      <a:noFill/>
-                    </a:lnT>
-                    <a:lnB w="7620">
-                      <a:noFill/>
-                    </a:lnB>
-                    <a:solidFill>
-                      <a:srgbClr val="FFFEF8"/>
-                    </a:solidFill>
-                  </a:tcPr>
-                </a:tc>
-                <a:tc>
-                  <a:txBody>
-                    <a:bodyPr wrap="square">
-                      <a:noAutofit/>
-                    </a:bodyPr>
-                    <a:lstStyle/>
-                    <a:p>
-                      <a:pPr algn="l">
-                        <a:lnSpc>
-                          <a:spcPts val="2127"/>
-                        </a:lnSpc>
-                        <a:buNone/>
-                        <a:defRPr sz="1850" b="0">
-                          <a:solidFill>
-                            <a:srgbClr val="303437"/>
-                          </a:solidFill>
-                          <a:latin typeface="Noto Sans"/>
-                        </a:defRPr>
-                      </a:pPr>
-                      <a:r>
-                        <a:rPr sz="1850" b="0" lang="ja-JP" altLang="en-US">
-                          <a:solidFill>
-                            <a:srgbClr val="303437"/>
-                          </a:solidFill>
-                          <a:latin typeface="Noto Sans"/>
-                          <a:ea typeface="Noto Sans CJK JP"/>
-                          <a:cs typeface="Noto Sans"/>
-                        </a:rPr>
-                        <a:t>1,000（test）</a:t>
-                      </a:r>
-                    </a:p>
-                  </a:txBody>
-                  <a:tcPr marL="63500" marR="63500" marT="38100" marB="38100" anchor="ctr">
-                    <a:lnL w="7620">
-                      <a:noFill/>
-                    </a:lnL>
-                    <a:lnR w="7620">
-                      <a:noFill/>
-                    </a:lnR>
-                    <a:lnT w="7620">
-                      <a:noFill/>
-                    </a:lnT>
-                    <a:lnB w="7620">
-                      <a:noFill/>
-                    </a:lnB>
-                    <a:solidFill>
-                      <a:srgbClr val="FFFEF8"/>
-                    </a:solidFill>
-                  </a:tcPr>
-                </a:tc>
-              </a:tr>
-              <a:tr h="420624">
-                <a:tc>
-                  <a:txBody>
-                    <a:bodyPr wrap="square">
-                      <a:noAutofit/>
-                    </a:bodyPr>
-                    <a:lstStyle/>
-                    <a:p>
-                      <a:pPr algn="l">
-                        <a:lnSpc>
-                          <a:spcPts val="2127"/>
-                        </a:lnSpc>
-                        <a:buNone/>
-                        <a:defRPr sz="1850" b="0">
-                          <a:solidFill>
-                            <a:srgbClr val="303437"/>
-                          </a:solidFill>
-                          <a:latin typeface="Noto Sans"/>
-                        </a:defRPr>
-                      </a:pPr>
-                      <a:r>
-                        <a:rPr sz="1850" b="0" lang="ja-JP" altLang="en-US">
-                          <a:solidFill>
-                            <a:srgbClr val="303437"/>
-                          </a:solidFill>
-                          <a:latin typeface="Noto Sans"/>
-                          <a:ea typeface="Noto Sans CJK JP"/>
-                          <a:cs typeface="Noto Sans"/>
-                        </a:rPr>
-                        <a:t>max_train_instances / 試行数</a:t>
-                      </a:r>
-                    </a:p>
-                  </a:txBody>
-                  <a:tcPr marL="63500" marR="63500" marT="38100" marB="38100" anchor="ctr">
-                    <a:lnL w="7620">
-                      <a:noFill/>
-                    </a:lnL>
-                    <a:lnR w="7620">
-                      <a:noFill/>
-                    </a:lnR>
-                    <a:lnT w="7620">
-                      <a:noFill/>
-                    </a:lnT>
-                    <a:lnB w="7620">
-                      <a:noFill/>
-                    </a:lnB>
-                    <a:solidFill>
-                      <a:srgbClr val="FFFEF8"/>
-                    </a:solidFill>
-                  </a:tcPr>
-                </a:tc>
-                <a:tc>
-                  <a:txBody>
-                    <a:bodyPr wrap="square">
-                      <a:noAutofit/>
-                    </a:bodyPr>
-                    <a:lstStyle/>
-                    <a:p>
-                      <a:pPr algn="l">
-                        <a:lnSpc>
-                          <a:spcPts val="2127"/>
-                        </a:lnSpc>
-                        <a:buNone/>
-                        <a:defRPr sz="1850" b="0">
-                          <a:solidFill>
-                            <a:srgbClr val="303437"/>
-                          </a:solidFill>
-                          <a:latin typeface="Noto Sans"/>
-                        </a:defRPr>
-                      </a:pPr>
-                      <a:r>
-                        <a:rPr sz="1850" b="0" lang="ja-JP" altLang="en-US">
-                          <a:solidFill>
-                            <a:srgbClr val="303437"/>
-                          </a:solidFill>
-                          <a:latin typeface="Noto Sans"/>
-                          <a:ea typeface="Noto Sans CJK JP"/>
-                          <a:cs typeface="Noto Sans"/>
-                        </a:rPr>
-                        <a:t>0 / 1</a:t>
-                      </a:r>
-                    </a:p>
-                  </a:txBody>
-                  <a:tcPr marL="63500" marR="63500" marT="38100" marB="38100" anchor="ctr">
-                    <a:lnL w="7620">
-                      <a:noFill/>
-                    </a:lnL>
-                    <a:lnR w="7620">
-                      <a:noFill/>
-                    </a:lnR>
-                    <a:lnT w="7620">
-                      <a:noFill/>
-                    </a:lnT>
-                    <a:lnB w="7620">
-                      <a:noFill/>
-                    </a:lnB>
-                    <a:solidFill>
-                      <a:srgbClr val="FFFEF8"/>
-                    </a:solidFill>
-                  </a:tcPr>
-                </a:tc>
-              </a:tr>
-              <a:tr h="420624">
-                <a:tc>
-                  <a:txBody>
-                    <a:bodyPr wrap="square">
-                      <a:noAutofit/>
-                    </a:bodyPr>
-                    <a:lstStyle/>
-                    <a:p>
-                      <a:pPr algn="l">
-                        <a:lnSpc>
-                          <a:spcPts val="2127"/>
-                        </a:lnSpc>
-                        <a:buNone/>
-                        <a:defRPr sz="1850" b="0">
-                          <a:solidFill>
-                            <a:srgbClr val="303437"/>
-                          </a:solidFill>
-                          <a:latin typeface="Noto Sans"/>
-                        </a:defRPr>
-                      </a:pPr>
-                      <a:r>
-                        <a:rPr sz="1850" b="0" lang="ja-JP" altLang="en-US">
-                          <a:solidFill>
-                            <a:srgbClr val="303437"/>
-                          </a:solidFill>
-                          <a:latin typeface="Noto Sans"/>
-                          <a:ea typeface="Noto Sans CJK JP"/>
-                          <a:cs typeface="Noto Sans"/>
-                        </a:rPr>
-                        <a:t>temperature / max_tokens</a:t>
-                      </a:r>
-                    </a:p>
-                  </a:txBody>
-                  <a:tcPr marL="63500" marR="63500" marT="38100" marB="38100" anchor="ctr">
-                    <a:lnL w="7620">
-                      <a:noFill/>
-                    </a:lnL>
-                    <a:lnR w="7620">
-                      <a:noFill/>
-                    </a:lnR>
-                    <a:lnT w="7620">
-                      <a:noFill/>
-                    </a:lnT>
-                    <a:lnB w="7620">
-                      <a:noFill/>
-                    </a:lnB>
-                    <a:solidFill>
-                      <a:srgbClr val="FFFEF8"/>
-                    </a:solidFill>
-                  </a:tcPr>
-                </a:tc>
-                <a:tc>
-                  <a:txBody>
-                    <a:bodyPr wrap="square">
-                      <a:noAutofit/>
-                    </a:bodyPr>
-                    <a:lstStyle/>
-                    <a:p>
-                      <a:pPr algn="l">
-                        <a:lnSpc>
-                          <a:spcPts val="2127"/>
-                        </a:lnSpc>
-                        <a:buNone/>
-                        <a:defRPr sz="1850" b="0">
-                          <a:solidFill>
-                            <a:srgbClr val="303437"/>
-                          </a:solidFill>
-                          <a:latin typeface="Noto Sans"/>
-                        </a:defRPr>
-                      </a:pPr>
-                      <a:r>
-                        <a:rPr sz="1850" b="0" lang="ja-JP" altLang="en-US">
-                          <a:solidFill>
-                            <a:srgbClr val="303437"/>
-                          </a:solidFill>
-                          <a:latin typeface="Noto Sans"/>
-                          <a:ea typeface="Noto Sans CJK JP"/>
-                          <a:cs typeface="Noto Sans"/>
-                        </a:rPr>
-                        <a:t>0 / 0</a:t>
-                      </a:r>
-                    </a:p>
-                  </a:txBody>
-                  <a:tcPr marL="63500" marR="63500" marT="38100" marB="38100" anchor="ctr">
-                    <a:lnL w="7620">
-                      <a:noFill/>
-                    </a:lnL>
-                    <a:lnR w="7620">
-                      <a:noFill/>
-                    </a:lnR>
-                    <a:lnT w="7620">
-                      <a:noFill/>
-                    </a:lnT>
-                    <a:lnB w="7620">
-                      <a:noFill/>
-                    </a:lnB>
-                    <a:solidFill>
-                      <a:srgbClr val="FFFEF8"/>
-                    </a:solidFill>
-                  </a:tcPr>
-                </a:tc>
-              </a:tr>
-              <a:tr h="420624">
-                <a:tc>
-                  <a:txBody>
-                    <a:bodyPr wrap="square">
-                      <a:noAutofit/>
-                    </a:bodyPr>
-                    <a:lstStyle/>
-                    <a:p>
-                      <a:pPr algn="l">
-                        <a:lnSpc>
-                          <a:spcPts val="2127"/>
-                        </a:lnSpc>
-                        <a:buNone/>
-                        <a:defRPr sz="1850" b="0">
-                          <a:solidFill>
-                            <a:srgbClr val="303437"/>
-                          </a:solidFill>
-                          <a:latin typeface="Noto Sans"/>
-                        </a:defRPr>
-                      </a:pPr>
-                      <a:r>
-                        <a:rPr sz="1850" b="0" lang="ja-JP" altLang="en-US">
-                          <a:solidFill>
-                            <a:srgbClr val="303437"/>
-                          </a:solidFill>
-                          <a:latin typeface="Noto Sans"/>
-                          <a:ea typeface="Noto Sans CJK JP"/>
-                          <a:cs typeface="Noto Sans"/>
-                        </a:rPr>
-                        <a:t>prompt_truncated</a:t>
-                      </a:r>
-                    </a:p>
-                  </a:txBody>
-                  <a:tcPr marL="63500" marR="63500" marT="38100" marB="38100" anchor="ctr">
-                    <a:lnL w="7620">
-                      <a:noFill/>
-                    </a:lnL>
-                    <a:lnR w="7620">
-                      <a:noFill/>
-                    </a:lnR>
-                    <a:lnT w="7620">
-                      <a:noFill/>
-                    </a:lnT>
-                    <a:lnB w="15240">
-                      <a:solidFill>
-                        <a:srgbClr val="626669"/>
-                      </a:solidFill>
-                      <a:prstDash val="solid"/>
-                    </a:lnB>
-                    <a:solidFill>
-                      <a:srgbClr val="FFFEF8"/>
-                    </a:solidFill>
-                  </a:tcPr>
-                </a:tc>
-                <a:tc>
-                  <a:txBody>
-                    <a:bodyPr wrap="square">
-                      <a:noAutofit/>
-                    </a:bodyPr>
-                    <a:lstStyle/>
-                    <a:p>
-                      <a:pPr algn="l">
-                        <a:lnSpc>
-                          <a:spcPts val="2127"/>
-                        </a:lnSpc>
-                        <a:buNone/>
-                        <a:defRPr sz="1850" b="0">
-                          <a:solidFill>
-                            <a:srgbClr val="303437"/>
-                          </a:solidFill>
-                          <a:latin typeface="Noto Sans"/>
-                        </a:defRPr>
-                      </a:pPr>
-                      <a:r>
-                        <a:rPr sz="1850" b="0" lang="ja-JP" altLang="en-US">
-                          <a:solidFill>
-                            <a:srgbClr val="303437"/>
-                          </a:solidFill>
-                          <a:latin typeface="Noto Sans"/>
-                          <a:ea typeface="Noto Sans CJK JP"/>
-                          <a:cs typeface="Noto Sans"/>
-                        </a:rPr>
-                        <a:t>0（両モデル・両条件）</a:t>
-                      </a:r>
-                    </a:p>
-                  </a:txBody>
-                  <a:tcPr marL="63500" marR="63500" marT="38100" marB="38100" anchor="ctr">
-                    <a:lnL w="7620">
-                      <a:noFill/>
-                    </a:lnL>
-                    <a:lnR w="7620">
-                      <a:noFill/>
-                    </a:lnR>
-                    <a:lnT w="7620">
-                      <a:noFill/>
-                    </a:lnT>
-                    <a:lnB w="15240">
-                      <a:solidFill>
-                        <a:srgbClr val="626669"/>
-                      </a:solidFill>
-                      <a:prstDash val="solid"/>
-                    </a:lnB>
-                    <a:solidFill>
-                      <a:srgbClr val="FFFEF8"/>
-                    </a:solidFill>
-                  </a:tcPr>
-                </a:tc>
-              </a:tr>
-            </a:tbl>
-          </a:graphicData>
-        </a:graphic>
-      </p:graphicFrame>
+              <a:t>Appendix: 2. 入力と指標の補足</a:t>
+            </a:r>
+          </a:p>
+        </p:txBody>
+      </p:sp>
       <p:sp>
         <p:nvSpPr>
           <p:cNvPr id="5" name="TextBox 4"/>
@@ -21855,8 +20910,8 @@
         </p:nvSpPr>
         <p:spPr>
           <a:xfrm>
-            <a:off x="594360" y="4233672"/>
-            <a:ext cx="7955279" cy="658368"/>
+            <a:off x="594360" y="3429000"/>
+            <a:ext cx="7955279" cy="822960"/>
           </a:xfrm>
           <a:prstGeom prst="rect">
             <a:avLst/>
@@ -21896,7 +20951,7 @@
                 <a:ea typeface="Noto Sans CJK JP"/>
                 <a:cs typeface="Noto Sans"/>
               </a:rPr>
-              <a:t>生成した回答の採点ではなく、echo_promptで既存の投稿の確率を取得する。</a:t>
+              <a:t>公開されたscenario_state.jsonには、評価に使った投稿とリクエストを収める。最初の投稿のinput.textを取り出す。</a:t>
             </a:r>
           </a:p>
         </p:txBody>
@@ -21950,7 +21005,7 @@
                 <a:ea typeface="Noto Sans CJK JP"/>
                 <a:cs typeface="Noto Sans"/>
               </a:rPr>
-              <a:t>[1] Stanford CRFM, HELM Classic v0.4.0, TwitterAAE. 公開実行suite v0.3.0。</a:t>
+              <a:t>[1] Stanford CRFM. HELM Classic v0.4.0 — TwitterAAE.  </a:t>
             </a:r>
             <a:r>
               <a:rPr sz="810" b="0" lang="ja-JP" altLang="en-US">
@@ -21960,20 +21015,132 @@
                 <a:latin typeface="Noto Sans"/>
                 <a:ea typeface="Noto Sans CJK JP"/>
                 <a:cs typeface="Noto Sans"/>
-              </a:rPr>
-              <a:t>  </a:t>
-            </a:r>
-            <a:r>
-              <a:rPr sz="810" b="0" lang="ja-JP" altLang="en-US">
-                <a:solidFill>
-                  <a:srgbClr val="626669"/>
-                </a:solidFill>
-                <a:latin typeface="Noto Sans"/>
-                <a:ea typeface="Noto Sans CJK JP"/>
-                <a:cs typeface="Noto Sans"/>
                 <a:hlinkClick r:id="rId2"/>
               </a:rPr>
               <a:t>https://crfm.stanford.edu/helm/classic/v0.4.0/#/groups/twitter_aae</a:t>
+            </a:r>
+          </a:p>
+        </p:txBody>
+      </p:sp>
+      <p:sp>
+        <p:nvSpPr>
+          <p:cNvPr id="7" name="code-frame"/>
+          <p:cNvSpPr txBox="1"/>
+          <p:nvPr/>
+        </p:nvSpPr>
+        <p:spPr>
+          <a:xfrm>
+            <a:off x="594360" y="1651000"/>
+            <a:ext cx="7955279" cy="1414018"/>
+          </a:xfrm>
+          <a:prstGeom prst="rect">
+            <a:avLst/>
+          </a:prstGeom>
+          <a:solidFill>
+            <a:srgbClr val="EBEDEB"/>
+          </a:solidFill>
+          <a:ln>
+            <a:noFill/>
+          </a:ln>
+        </p:spPr>
+        <p:txBody>
+          <a:bodyPr wrap="none" lIns="152400" rIns="152400" tIns="76200" bIns="127000">
+            <a:spAutoFit/>
+          </a:bodyPr>
+          <a:lstStyle/>
+          <a:p>
+            <a:pPr>
+              <a:lnSpc>
+                <a:spcPts val="1900"/>
+              </a:lnSpc>
+              <a:spcAft>
+                <a:spcPts val="0"/>
+              </a:spcAft>
+              <a:defRPr sz="1550">
+                <a:solidFill>
+                  <a:srgbClr val="303437"/>
+                </a:solidFill>
+                <a:latin typeface="DejaVu Sans Mono"/>
+              </a:defRPr>
+            </a:pPr>
+            <a:r>
+              <a:t>import json</a:t>
+            </a:r>
+          </a:p>
+          <a:p>
+            <a:pPr>
+              <a:lnSpc>
+                <a:spcPts val="1900"/>
+              </a:lnSpc>
+              <a:spcAft>
+                <a:spcPts val="0"/>
+              </a:spcAft>
+              <a:defRPr sz="1550">
+                <a:solidFill>
+                  <a:srgbClr val="303437"/>
+                </a:solidFill>
+                <a:latin typeface="DejaVu Sans Mono"/>
+              </a:defRPr>
+            </a:pPr>
+            <a:r>
+              <a:t>with open("scenario_state.json", encoding="utf-8") as f:</a:t>
+            </a:r>
+          </a:p>
+          <a:p>
+            <a:pPr>
+              <a:lnSpc>
+                <a:spcPts val="1900"/>
+              </a:lnSpc>
+              <a:spcAft>
+                <a:spcPts val="0"/>
+              </a:spcAft>
+              <a:defRPr sz="1550">
+                <a:solidFill>
+                  <a:srgbClr val="303437"/>
+                </a:solidFill>
+                <a:latin typeface="DejaVu Sans Mono"/>
+              </a:defRPr>
+            </a:pPr>
+            <a:r>
+              <a:t>    state = json.load(f)</a:t>
+            </a:r>
+          </a:p>
+          <a:p>
+            <a:pPr>
+              <a:lnSpc>
+                <a:spcPts val="1900"/>
+              </a:lnSpc>
+              <a:spcAft>
+                <a:spcPts val="0"/>
+              </a:spcAft>
+              <a:defRPr sz="1550">
+                <a:solidFill>
+                  <a:srgbClr val="303437"/>
+                </a:solidFill>
+                <a:latin typeface="DejaVu Sans Mono"/>
+              </a:defRPr>
+            </a:pPr>
+            <a:r>
+              <a:t>post = state["request_states"][0]["instance"]</a:t>
+            </a:r>
+          </a:p>
+          <a:p>
+            <a:pPr>
+              <a:lnSpc>
+                <a:spcPts val="1900"/>
+              </a:lnSpc>
+              <a:spcAft>
+                <a:spcPts val="0"/>
+              </a:spcAft>
+              <a:defRPr sz="1550">
+                <a:solidFill>
+                  <a:srgbClr val="303437"/>
+                </a:solidFill>
+                <a:latin typeface="DejaVu Sans Mono"/>
+              </a:defRPr>
+            </a:pPr>
+            <a:r>
+              <a:t>print(post["input"]["text"])</a:t>
             </a:r>
           </a:p>
         </p:txBody>
@@ -22039,7 +21206,7 @@
                 <a:ea typeface="Noto Sans CJK JP"/>
                 <a:cs typeface="Noto Sans"/>
               </a:rPr>
-              <a:t>BPBは投稿ごとの比を単純平均しない</a:t>
+              <a:t>BPBは、全投稿の総byte数で割って求める</a:t>
             </a:r>
           </a:p>
         </p:txBody>
@@ -22087,7 +21254,7 @@
                 <a:ea typeface="Noto Sans CJK JP"/>
                 <a:cs typeface="Noto Sans"/>
               </a:rPr>
-              <a:t>Appendix: 2. 版・実行条件の補足</a:t>
+              <a:t>Appendix: 2. 入力と指標の補足</a:t>
             </a:r>
           </a:p>
         </p:txBody>
@@ -22195,7 +21362,7 @@
                 <a:ea typeface="Noto Sans CJK JP"/>
                 <a:cs typeface="Noto Sans"/>
               </a:rPr>
-              <a:t>投稿ごとの長さで重みが変わる、総byte数による集約。トークン単位のperplexityとは分母が異なる。</a:t>
+              <a:t>すべての投稿の対数確率とbyte数を合計してから計算するため、長い投稿ほど大きな重みを持つ。</a:t>
             </a:r>
           </a:p>
         </p:txBody>
@@ -22303,7 +21470,19 @@
                 <a:ea typeface="Noto Sans CJK JP"/>
                 <a:cs typeface="Noto Sans"/>
               </a:rPr>
-              <a:t>[1] Stanford CRFM, HELM BasicMetrics. 対数確率・byte数からの集約。2026-10-18確認。</a:t>
+              <a:t>[1] Stanford CRFM. HELM BasicMetrics.  </a:t>
+            </a:r>
+            <a:r>
+              <a:rPr sz="810" b="0" lang="ja-JP" altLang="en-US">
+                <a:solidFill>
+                  <a:srgbClr val="626669"/>
+                </a:solidFill>
+                <a:latin typeface="Noto Sans"/>
+                <a:ea typeface="Noto Sans CJK JP"/>
+                <a:cs typeface="Noto Sans"/>
+                <a:hlinkClick r:id="rId2"/>
+              </a:rPr>
+              <a:t>https://github.com/stanford-crfm/helm/blob/main/src/helm/benchmark/metrics/basic_metrics.py</a:t>
             </a:r>
           </a:p>
           <a:p>
@@ -22327,48 +21506,8 @@
                 <a:latin typeface="Noto Sans"/>
                 <a:ea typeface="Noto Sans CJK JP"/>
                 <a:cs typeface="Noto Sans"/>
-                <a:hlinkClick r:id="rId2"/>
-              </a:rPr>
-              <a:t>https://github.com/stanford-crfm/helm/blob/main/src/helm/benchmark/metrics/basic_metrics.py</a:t>
-            </a:r>
-          </a:p>
-          <a:p>
-            <a:pPr>
-              <a:lnSpc>
-                <a:spcPts val="1150"/>
-              </a:lnSpc>
-              <a:spcAft>
-                <a:spcPts val="140"/>
-              </a:spcAft>
-              <a:buNone/>
-              <a:defRPr sz="810" b="0">
-                <a:solidFill>
-                  <a:srgbClr val="303437"/>
-                </a:solidFill>
-                <a:latin typeface="Noto Sans"/>
-              </a:defRPr>
-            </a:pPr>
-            <a:r>
-              <a:rPr sz="810" b="0" lang="ja-JP" altLang="en-US">
-                <a:solidFill>
-                  <a:srgbClr val="626669"/>
-                </a:solidFill>
-                <a:latin typeface="Noto Sans"/>
-                <a:ea typeface="Noto Sans CJK JP"/>
-                <a:cs typeface="Noto Sans"/>
-              </a:rPr>
-              <a:t>[2] Stanford CRFM, HELM Classic v0.4.0, TwitterAAE. 公開実行suite v0.3.0。</a:t>
-            </a:r>
-            <a:r>
-              <a:rPr sz="810" b="0" lang="ja-JP" altLang="en-US">
-                <a:solidFill>
-                  <a:srgbClr val="626669"/>
-                </a:solidFill>
-                <a:latin typeface="Noto Sans"/>
-                <a:ea typeface="Noto Sans CJK JP"/>
-                <a:cs typeface="Noto Sans"/>
-              </a:rPr>
-              <a:t>  </a:t>
+              </a:rPr>
+              <a:t>[2] Stanford CRFM. HELM Classic v0.4.0 — TwitterAAE.  </a:t>
             </a:r>
             <a:r>
               <a:rPr sz="810" b="0" lang="ja-JP" altLang="en-US">
@@ -22494,7 +21633,7 @@
                 <a:ea typeface="Noto Sans CJK JP"/>
                 <a:cs typeface="Noto Sans"/>
               </a:rPr>
-              <a:t>Appendix: 2. 版・実行条件の補足</a:t>
+              <a:t>Appendix: 2. 入力と指標の補足</a:t>
             </a:r>
           </a:p>
         </p:txBody>
@@ -23119,7 +22258,7 @@
                 <a:ea typeface="Noto Sans CJK JP"/>
                 <a:cs typeface="Noto Sans"/>
               </a:rPr>
-              <a:t>[1] Stanford CRFM, HELM Classic v0.4.0, TwitterAAE. 公開実行suite v0.3.0。</a:t>
+              <a:t>[1] Stanford CRFM. HELM Classic v0.4.0 — TwitterAAE.  </a:t>
             </a:r>
             <a:r>
               <a:rPr sz="810" b="0" lang="ja-JP" altLang="en-US">
@@ -23129,373 +22268,9 @@
                 <a:latin typeface="Noto Sans"/>
                 <a:ea typeface="Noto Sans CJK JP"/>
                 <a:cs typeface="Noto Sans"/>
-              </a:rPr>
-              <a:t>  </a:t>
-            </a:r>
-            <a:r>
-              <a:rPr sz="810" b="0" lang="ja-JP" altLang="en-US">
-                <a:solidFill>
-                  <a:srgbClr val="626669"/>
-                </a:solidFill>
-                <a:latin typeface="Noto Sans"/>
-                <a:ea typeface="Noto Sans CJK JP"/>
-                <a:cs typeface="Noto Sans"/>
                 <a:hlinkClick r:id="rId2"/>
               </a:rPr>
               <a:t>https://crfm.stanford.edu/helm/classic/v0.4.0/#/groups/twitter_aae</a:t>
-            </a:r>
-          </a:p>
-        </p:txBody>
-      </p:sp>
-    </p:spTree>
-  </p:cSld>
-  <p:clrMapOvr>
-    <a:masterClrMapping/>
-  </p:clrMapOvr>
-</p:sld>
-</file>
-
-<file path=ppt/slides/slide45.xml><?xml version="1.0" encoding="utf-8"?>
-<p:sld xmlns:a="http://schemas.openxmlformats.org/drawingml/2006/main" xmlns:p="http://schemas.openxmlformats.org/presentationml/2006/main" xmlns:r="http://schemas.openxmlformats.org/officeDocument/2006/relationships">
-  <p:cSld>
-    <p:spTree>
-      <p:nvGrpSpPr>
-        <p:cNvPr id="1" name=""/>
-        <p:cNvGrpSpPr/>
-        <p:nvPr/>
-      </p:nvGrpSpPr>
-      <p:grpSpPr/>
-      <p:sp>
-        <p:nvSpPr>
-          <p:cNvPr id="2" name="Title 1"/>
-          <p:cNvSpPr>
-            <a:spLocks noGrp="1"/>
-          </p:cNvSpPr>
-          <p:nvPr>
-            <p:ph type="title"/>
-          </p:nvPr>
-        </p:nvSpPr>
-        <p:spPr>
-          <a:xfrm>
-            <a:off x="468172" y="650138"/>
-            <a:ext cx="8206740" cy="616305"/>
-          </a:xfrm>
-        </p:spPr>
-        <p:txBody>
-          <a:bodyPr wrap="square" lIns="0" rIns="0" tIns="0" bIns="0">
-            <a:noAutofit/>
-          </a:bodyPr>
-          <a:lstStyle/>
-          <a:p>
-            <a:pPr algn="l">
-              <a:lnSpc>
-                <a:spcPct val="110000"/>
-              </a:lnSpc>
-              <a:buNone/>
-              <a:defRPr sz="2800" b="0">
-                <a:solidFill>
-                  <a:srgbClr val="303437"/>
-                </a:solidFill>
-                <a:latin typeface="Noto Sans"/>
-              </a:defRPr>
-            </a:pPr>
-            <a:r>
-              <a:rPr sz="2800" b="1" lang="ja-JP" altLang="en-US">
-                <a:solidFill>
-                  <a:srgbClr val="303437"/>
-                </a:solidFill>
-                <a:latin typeface="Noto Sans"/>
-                <a:ea typeface="Noto Sans CJK JP"/>
-                <a:cs typeface="Noto Sans"/>
-              </a:rPr>
-              <a:t>公開範囲と取得できた範囲</a:t>
-            </a:r>
-          </a:p>
-        </p:txBody>
-      </p:sp>
-      <p:sp>
-        <p:nvSpPr>
-          <p:cNvPr id="3" name="Title 2"/>
-          <p:cNvSpPr>
-            <a:spLocks noGrp="1"/>
-          </p:cNvSpPr>
-          <p:nvPr>
-            <p:ph type="title" idx="2"/>
-          </p:nvPr>
-        </p:nvSpPr>
-        <p:spPr>
-          <a:xfrm>
-            <a:off x="75895" y="0"/>
-            <a:ext cx="8115300" cy="480060"/>
-          </a:xfrm>
-        </p:spPr>
-        <p:txBody>
-          <a:bodyPr wrap="square" lIns="0" rIns="0" tIns="0" bIns="0" anchor="ctr">
-            <a:noAutofit/>
-          </a:bodyPr>
-          <a:lstStyle/>
-          <a:p>
-            <a:pPr algn="l">
-              <a:lnSpc>
-                <a:spcPct val="110000"/>
-              </a:lnSpc>
-              <a:buNone/>
-              <a:defRPr sz="1400" b="0">
-                <a:solidFill>
-                  <a:srgbClr val="303437"/>
-                </a:solidFill>
-                <a:latin typeface="Noto Sans"/>
-              </a:defRPr>
-            </a:pPr>
-            <a:r>
-              <a:rPr sz="1400" b="1" lang="ja-JP" altLang="en-US">
-                <a:solidFill>
-                  <a:srgbClr val="FFFEF8"/>
-                </a:solidFill>
-                <a:latin typeface="Noto Sans"/>
-                <a:ea typeface="Noto Sans CJK JP"/>
-                <a:cs typeface="Noto Sans"/>
-              </a:rPr>
-              <a:t>Appendix: 2. 版・実行条件の補足</a:t>
-            </a:r>
-          </a:p>
-        </p:txBody>
-      </p:sp>
-      <p:sp>
-        <p:nvSpPr>
-          <p:cNvPr id="4" name="TextBox 3"/>
-          <p:cNvSpPr txBox="1"/>
-          <p:nvPr/>
-        </p:nvSpPr>
-        <p:spPr>
-          <a:xfrm>
-            <a:off x="594360" y="1463040"/>
-            <a:ext cx="7955279" cy="680466"/>
-          </a:xfrm>
-          <a:prstGeom prst="rect">
-            <a:avLst/>
-          </a:prstGeom>
-          <a:noFill/>
-        </p:spPr>
-        <p:txBody>
-          <a:bodyPr wrap="square" lIns="0" rIns="0" tIns="0" bIns="0">
-            <a:noAutofit/>
-          </a:bodyPr>
-          <a:lstStyle/>
-          <a:p>
-            <a:pPr algn="l">
-              <a:lnSpc>
-                <a:spcPts val="2499"/>
-              </a:lnSpc>
-              <a:spcBef>
-                <a:spcPts val="0"/>
-              </a:spcBef>
-              <a:spcAft>
-                <a:spcPts val="0"/>
-              </a:spcAft>
-              <a:buNone/>
-              <a:defRPr sz="2100" b="0">
-                <a:solidFill>
-                  <a:srgbClr val="303437"/>
-                </a:solidFill>
-                <a:latin typeface="Noto Sans"/>
-              </a:defRPr>
-            </a:pPr>
-            <a:r>
-              <a:rPr sz="2100" b="0" lang="ja-JP" altLang="en-US">
-                <a:solidFill>
-                  <a:srgbClr val="303437"/>
-                </a:solidFill>
-                <a:latin typeface="Noto Sans"/>
-                <a:ea typeface="Noto Sans CJK JP"/>
-                <a:cs typeface="Noto Sans"/>
-              </a:rPr>
-              <a:t>公式の全体ZIP（5.5 GB）は未取得。公式UD配布ZIPと公開HELM入力2,000件を取得し、13実例は後者から選定した。</a:t>
-            </a:r>
-          </a:p>
-        </p:txBody>
-      </p:sp>
-      <p:sp>
-        <p:nvSpPr>
-          <p:cNvPr id="5" name="TextBox 4"/>
-          <p:cNvSpPr txBox="1"/>
-          <p:nvPr/>
-        </p:nvSpPr>
-        <p:spPr>
-          <a:xfrm>
-            <a:off x="594360" y="2308098"/>
-            <a:ext cx="7955279" cy="680466"/>
-          </a:xfrm>
-          <a:prstGeom prst="rect">
-            <a:avLst/>
-          </a:prstGeom>
-          <a:noFill/>
-        </p:spPr>
-        <p:txBody>
-          <a:bodyPr wrap="square" lIns="0" rIns="0" tIns="0" bIns="0">
-            <a:noAutofit/>
-          </a:bodyPr>
-          <a:lstStyle/>
-          <a:p>
-            <a:pPr algn="l">
-              <a:lnSpc>
-                <a:spcPts val="2499"/>
-              </a:lnSpc>
-              <a:spcBef>
-                <a:spcPts val="0"/>
-              </a:spcBef>
-              <a:spcAft>
-                <a:spcPts val="0"/>
-              </a:spcAft>
-              <a:buNone/>
-              <a:defRPr sz="2100" b="0">
-                <a:solidFill>
-                  <a:srgbClr val="303437"/>
-                </a:solidFill>
-                <a:latin typeface="Noto Sans"/>
-              </a:defRPr>
-            </a:pPr>
-            <a:r>
-              <a:rPr sz="2100" b="0" lang="ja-JP" altLang="en-US">
-                <a:solidFill>
-                  <a:srgbClr val="303437"/>
-                </a:solidFill>
-                <a:latin typeface="Noto Sans"/>
-                <a:ea typeface="Noto Sans CJK JP"/>
-                <a:cs typeface="Noto Sans"/>
-              </a:rPr>
-              <a:t>公式サイトは研究目的での利用と論文の引用を求めている。投稿本文についての包括的な再配布許諾は確認できなかった。</a:t>
-            </a:r>
-          </a:p>
-        </p:txBody>
-      </p:sp>
-      <p:sp>
-        <p:nvSpPr>
-          <p:cNvPr id="6" name="TextBox 5"/>
-          <p:cNvSpPr txBox="1"/>
-          <p:nvPr/>
-        </p:nvSpPr>
-        <p:spPr>
-          <a:xfrm>
-            <a:off x="594360" y="3153156"/>
-            <a:ext cx="7955279" cy="680466"/>
-          </a:xfrm>
-          <a:prstGeom prst="rect">
-            <a:avLst/>
-          </a:prstGeom>
-          <a:noFill/>
-        </p:spPr>
-        <p:txBody>
-          <a:bodyPr wrap="square" lIns="0" rIns="0" tIns="0" bIns="0">
-            <a:noAutofit/>
-          </a:bodyPr>
-          <a:lstStyle/>
-          <a:p>
-            <a:pPr algn="l">
-              <a:lnSpc>
-                <a:spcPts val="2499"/>
-              </a:lnSpc>
-              <a:spcBef>
-                <a:spcPts val="0"/>
-              </a:spcBef>
-              <a:spcAft>
-                <a:spcPts val="0"/>
-              </a:spcAft>
-              <a:buNone/>
-              <a:defRPr sz="2100" b="0">
-                <a:solidFill>
-                  <a:srgbClr val="303437"/>
-                </a:solidFill>
-                <a:latin typeface="Noto Sans"/>
-              </a:defRPr>
-            </a:pPr>
-            <a:r>
-              <a:rPr sz="2100" b="0" lang="ja-JP" altLang="en-US">
-                <a:solidFill>
-                  <a:srgbClr val="303437"/>
-                </a:solidFill>
-                <a:latin typeface="Noto Sans"/>
-                <a:ea typeface="Noto Sans CJK JP"/>
-                <a:cs typeface="Noto Sans"/>
-              </a:rPr>
-              <a:t>原文、訳、条件内ID、固定実行URL、原レコード、取得ファイルのSHA-256を制作記録へ保存した。</a:t>
-            </a:r>
-          </a:p>
-        </p:txBody>
-      </p:sp>
-      <p:sp>
-        <p:nvSpPr>
-          <p:cNvPr id="7" name="sources"/>
-          <p:cNvSpPr txBox="1"/>
-          <p:nvPr/>
-        </p:nvSpPr>
-        <p:spPr>
-          <a:xfrm>
-            <a:off x="502920" y="4700016"/>
-            <a:ext cx="8183879" cy="530352"/>
-          </a:xfrm>
-          <a:prstGeom prst="rect">
-            <a:avLst/>
-          </a:prstGeom>
-          <a:noFill/>
-        </p:spPr>
-        <p:txBody>
-          <a:bodyPr wrap="square" lIns="0" rIns="0" tIns="0" bIns="0">
-            <a:noAutofit/>
-          </a:bodyPr>
-          <a:lstStyle/>
-          <a:p>
-            <a:pPr algn="l">
-              <a:lnSpc>
-                <a:spcPts val="940"/>
-              </a:lnSpc>
-              <a:spcBef>
-                <a:spcPts val="0"/>
-              </a:spcBef>
-              <a:spcAft>
-                <a:spcPts val="140"/>
-              </a:spcAft>
-              <a:buNone/>
-              <a:defRPr sz="810" b="0">
-                <a:solidFill>
-                  <a:srgbClr val="303437"/>
-                </a:solidFill>
-                <a:latin typeface="Noto Sans"/>
-              </a:defRPr>
-            </a:pPr>
-            <a:r>
-              <a:rPr sz="810" b="0" lang="ja-JP" altLang="en-US">
-                <a:solidFill>
-                  <a:srgbClr val="626669"/>
-                </a:solidFill>
-                <a:latin typeface="Noto Sans"/>
-                <a:ea typeface="Noto Sans CJK JP"/>
-                <a:cs typeface="Noto Sans"/>
-              </a:rPr>
-              <a:t>[1] UMass SLANG Lab (n.d.), TwitterAAE: Research on African-American English on Twitter. 2026-10-18参照。</a:t>
-            </a:r>
-            <a:r>
-              <a:rPr sz="810" b="0" lang="ja-JP" altLang="en-US">
-                <a:solidFill>
-                  <a:srgbClr val="626669"/>
-                </a:solidFill>
-                <a:latin typeface="Noto Sans"/>
-                <a:ea typeface="Noto Sans CJK JP"/>
-                <a:cs typeface="Noto Sans"/>
-              </a:rPr>
-              <a:t>  </a:t>
-            </a:r>
-            <a:r>
-              <a:rPr sz="810" b="0" lang="ja-JP" altLang="en-US">
-                <a:solidFill>
-                  <a:srgbClr val="626669"/>
-                </a:solidFill>
-                <a:latin typeface="Noto Sans"/>
-                <a:ea typeface="Noto Sans CJK JP"/>
-                <a:cs typeface="Noto Sans"/>
-                <a:hlinkClick r:id="rId2"/>
-              </a:rPr>
-              <a:t>https://slanglab.cs.umass.edu/TwitterAAE/</a:t>
             </a:r>
           </a:p>
         </p:txBody>
@@ -24147,7 +22922,7 @@
         <p:spPr>
           <a:xfrm>
             <a:off x="548640" y="1463040"/>
-            <a:ext cx="8046720" cy="1628140"/>
+            <a:ext cx="8046720" cy="1856740"/>
           </a:xfrm>
           <a:prstGeom prst="rect">
             <a:avLst/>
@@ -24295,7 +23070,7 @@
         <p:spPr>
           <a:xfrm>
             <a:off x="548640" y="3322828"/>
-            <a:ext cx="8046720" cy="1374775"/>
+            <a:ext cx="8046720" cy="1603375"/>
           </a:xfrm>
           <a:prstGeom prst="rect">
             <a:avLst/>
@@ -24557,7 +23332,7 @@
         <p:spPr>
           <a:xfrm>
             <a:off x="548640" y="1463040"/>
-            <a:ext cx="8046720" cy="1360297"/>
+            <a:ext cx="8046720" cy="1588897"/>
           </a:xfrm>
           <a:prstGeom prst="rect">
             <a:avLst/>
@@ -24705,7 +23480,7 @@
         <p:spPr>
           <a:xfrm>
             <a:off x="548640" y="3054985"/>
-            <a:ext cx="8046720" cy="1106932"/>
+            <a:ext cx="8046720" cy="1335532"/>
           </a:xfrm>
           <a:prstGeom prst="rect">
             <a:avLst/>
@@ -25007,7 +23782,7 @@
                 <a:ea typeface="Noto Sans CJK JP"/>
                 <a:cs typeface="Noto Sans"/>
               </a:rPr>
-              <a:t>TwitterAAEは、Twitter上のAfrican-American English（AAE）に関連する言語を、地域の人口統計と言葉の共起から分析する資源。</a:t>
+              <a:t>TwitterAAEは、Twitter上のアフリカ系米国人英語（AAE）に関連する表現を調べる言語資源。投稿の位置に対応する地域の人口構成と、使われる言葉の関係から分析する。</a:t>
             </a:r>
           </a:p>
         </p:txBody>
@@ -25309,7 +24084,7 @@
                 <a:ea typeface="Noto Sans CJK JP"/>
                 <a:cs typeface="Noto Sans"/>
               </a:rPr>
-              <a:t>HELMは、AA寄り・white寄りの言語混合比で抽出した二つの投稿集合に、言語モデルが付ける確率を測る。</a:t>
+              <a:t>HELMでは、AA系・white系の言語的特徴が多い投稿をそれぞれ集め、言語モデルがどれだけ予測できるかを比べる。</a:t>
             </a:r>
           </a:p>
         </p:txBody>
@@ -25417,7 +24192,7 @@
                 <a:ea typeface="Noto Sans CJK JP"/>
                 <a:cs typeface="Noto Sans"/>
               </a:rPr>
-              <a:t>[1] Stanford CRFM, HELM TwitterAAEScenario. AA／whiteの抽出とtestインスタンス。2026-10-18確認。</a:t>
+              <a:t>[1] Stanford CRFM, HELM TwitterAAEScenario. </a:t>
             </a:r>
           </a:p>
           <a:p>
@@ -25433,6 +24208,17 @@
                 <a:latin typeface="Noto Sans"/>
               </a:defRPr>
             </a:pPr>
+            <a:r>
+              <a:rPr sz="810" b="0" lang="ja-JP" altLang="en-US">
+                <a:solidFill>
+                  <a:srgbClr val="626669"/>
+                </a:solidFill>
+                <a:latin typeface="Noto Sans"/>
+                <a:ea typeface="Noto Sans CJK JP"/>
+                <a:cs typeface="Noto Sans"/>
+              </a:rPr>
+              <a:t/>
+            </a:r>
             <a:r>
               <a:rPr sz="810" b="0" lang="ja-JP" altLang="en-US">
                 <a:solidFill>
@@ -25509,7 +24295,7 @@
                 <a:ea typeface="Noto Sans CJK JP"/>
                 <a:cs typeface="Noto Sans"/>
               </a:rPr>
-              <a:t>実例はHELMの公開実行入力から示す</a:t>
+              <a:t>AA・whiteは、言語の特徴に基づく抽出条件</a:t>
             </a:r>
           </a:p>
         </p:txBody>
@@ -25611,7 +24397,7 @@
                 <a:ea typeface="Noto Sans CJK JP"/>
                 <a:cs typeface="Noto Sans"/>
               </a:rPr>
-              <a:t>以下の3例とAppendixの10例は、公開されたscenario_stateから選んだ別々の投稿。元の大文字・つづり・句読点を保って全文を示す。</a:t>
+              <a:t>本編3例と追加10例は、HELMの公開評価に使われた13件の投稿全文。大文字や独自のつづり、句読点にも会話の特徴が現れる。</a:t>
             </a:r>
           </a:p>
         </p:txBody>
@@ -25665,7 +24451,7 @@
                 <a:ea typeface="Noto Sans CJK JP"/>
                 <a:cs typeface="Noto Sans"/>
               </a:rPr>
-              <a:t>aa／whiteはデータの抽出条件名。元の推定値は、人口統計に関連付けられた言語が文中で占める割合であり、話者の自己申告人種ではない。</a:t>
+              <a:t>aa／whiteは抽出条件の名前。地域の人口構成に関連する言語の混合比を使っており、投稿者の自己申告による人種を表すラベルではない。</a:t>
             </a:r>
           </a:p>
         </p:txBody>
@@ -25719,18 +24505,7 @@
                 <a:ea typeface="Noto Sans CJK JP"/>
                 <a:cs typeface="Noto Sans"/>
               </a:rPr>
-              <a:t>[1] Blodgett et al. (n.d.), twitteraae. 人口統計と言語を結ぶ混合モデルのREADME。2026-10-18参照。</a:t>
-            </a:r>
-            <a:r>
-              <a:rPr sz="810" b="0" lang="ja-JP" altLang="en-US">
-                <a:solidFill>
-                  <a:srgbClr val="626669"/>
-                </a:solidFill>
-                <a:latin typeface="Noto Sans"/>
-                <a:ea typeface="Noto Sans CJK JP"/>
-                <a:cs typeface="Noto Sans"/>
-              </a:rPr>
-              <a:t>  </a:t>
+              <a:t>[1] Blodgett et al. (n.d.), twitteraae. 人口統計と言語を結ぶ混合モデルのREADME。</a:t>
             </a:r>
             <a:r>
               <a:rPr sz="810" b="0" lang="ja-JP" altLang="en-US">
@@ -25923,8 +24698,8 @@
         </p:nvSpPr>
         <p:spPr>
           <a:xfrm>
-            <a:off x="548640" y="1673352"/>
-            <a:ext cx="8046720" cy="949198"/>
+            <a:off x="548640" y="1765300"/>
+            <a:ext cx="8046720" cy="736600"/>
           </a:xfrm>
           <a:prstGeom prst="rect">
             <a:avLst/>
@@ -25952,7 +24727,7 @@
           </a:fontRef>
         </p:style>
         <p:txBody>
-          <a:bodyPr rtlCol="0" anchor="t" wrap="square" lIns="177800" rIns="177800" tIns="101600" bIns="127000">
+          <a:bodyPr rtlCol="0" anchor="t" wrap="square" lIns="177800" rIns="177800" tIns="9652" bIns="127000">
             <a:noAutofit/>
           </a:bodyPr>
           <a:lstStyle/>
@@ -25997,7 +24772,7 @@
         </p:nvSpPr>
         <p:spPr>
           <a:xfrm>
-            <a:off x="594360" y="2823718"/>
+            <a:off x="594360" y="2703068"/>
             <a:ext cx="7955279" cy="228600"/>
           </a:xfrm>
           <a:prstGeom prst="rect">
@@ -26051,7 +24826,7 @@
         </p:nvSpPr>
         <p:spPr>
           <a:xfrm>
-            <a:off x="594360" y="3125470"/>
+            <a:off x="594360" y="3004820"/>
             <a:ext cx="7955279" cy="710692"/>
           </a:xfrm>
           <a:prstGeom prst="rect">
@@ -26105,7 +24880,7 @@
         </p:nvSpPr>
         <p:spPr>
           <a:xfrm>
-            <a:off x="594360" y="4019042"/>
+            <a:off x="594360" y="3898392"/>
             <a:ext cx="7955279" cy="594360"/>
           </a:xfrm>
           <a:prstGeom prst="rect">
@@ -26146,7 +24921,7 @@
                 <a:ea typeface="Noto Sans CJK JP"/>
                 <a:cs typeface="Noto Sans"/>
               </a:rPr>
-              <a:t>OOMFはone of my followersの略。大文字やつづりの工夫も、実際に採点された文字列の一部。</a:t>
+              <a:t>OOMFはone of my followers（フォロワーの一人）の略。FONEやJUSなど、発音に近づけたつづりも使う。</a:t>
             </a:r>
           </a:p>
         </p:txBody>
@@ -26200,22 +24975,8 @@
                 <a:ea typeface="Noto Sans CJK JP"/>
                 <a:cs typeface="Noto Sans"/>
               </a:rPr>
-              <a:t>[1] Stanford CRFM, HELM Classic v0.4.0, TwitterAAE. 公開実行suite v0.3.0。 instance: aa/id19602（HELM内ID）</a:t>
-            </a:r>
-          </a:p>
-          <a:p>
-            <a:pPr>
-              <a:lnSpc>
-                <a:spcPts val="940"/>
-              </a:lnSpc>
-              <a:buNone/>
-              <a:defRPr sz="810" b="0">
-                <a:solidFill>
-                  <a:srgbClr val="303437"/>
-                </a:solidFill>
-                <a:latin typeface="Noto Sans"/>
-              </a:defRPr>
-            </a:pPr>
+              <a:t>[1] Stanford CRFM. HELM Classic v0.4.0 — TwitterAAE.  </a:t>
+            </a:r>
             <a:r>
               <a:rPr sz="810" b="0" lang="ja-JP" altLang="en-US">
                 <a:solidFill>
@@ -26407,8 +25168,8 @@
         </p:nvSpPr>
         <p:spPr>
           <a:xfrm>
-            <a:off x="548640" y="1673352"/>
-            <a:ext cx="8046720" cy="601598"/>
+            <a:off x="548640" y="1756833"/>
+            <a:ext cx="8046720" cy="465667"/>
           </a:xfrm>
           <a:prstGeom prst="rect">
             <a:avLst/>
@@ -26436,7 +25197,7 @@
           </a:fontRef>
         </p:style>
         <p:txBody>
-          <a:bodyPr rtlCol="0" anchor="t" wrap="square" lIns="177800" rIns="177800" tIns="101600" bIns="127000">
+          <a:bodyPr rtlCol="0" anchor="t" wrap="square" lIns="177800" rIns="177800" tIns="18119" bIns="127000">
             <a:noAutofit/>
           </a:bodyPr>
           <a:lstStyle/>
@@ -26481,7 +25242,7 @@
         </p:nvSpPr>
         <p:spPr>
           <a:xfrm>
-            <a:off x="594360" y="2476119"/>
+            <a:off x="594360" y="2423670"/>
             <a:ext cx="7955279" cy="228600"/>
           </a:xfrm>
           <a:prstGeom prst="rect">
@@ -26535,7 +25296,7 @@
         </p:nvSpPr>
         <p:spPr>
           <a:xfrm>
-            <a:off x="594360" y="2777871"/>
+            <a:off x="594360" y="2725422"/>
             <a:ext cx="7955279" cy="378206"/>
           </a:xfrm>
           <a:prstGeom prst="rect">
@@ -26589,7 +25350,7 @@
         </p:nvSpPr>
         <p:spPr>
           <a:xfrm>
-            <a:off x="594360" y="3338957"/>
+            <a:off x="594360" y="3286508"/>
             <a:ext cx="7955279" cy="594360"/>
           </a:xfrm>
           <a:prstGeom prst="rect">
@@ -26630,7 +25391,7 @@
                 <a:ea typeface="Noto Sans CJK JP"/>
                 <a:cs typeface="Noto Sans"/>
               </a:rPr>
-              <a:t>bruhという呼びかけとwannaの縮約を含む。語りかけの調子を保って訳した。</a:t>
+              <a:t>bruhはくだけた呼びかけ。wannaはwant toの縮約で、短い投稿でも会話の調子が伝わる。</a:t>
             </a:r>
           </a:p>
         </p:txBody>
@@ -26684,22 +25445,8 @@
                 <a:ea typeface="Noto Sans CJK JP"/>
                 <a:cs typeface="Noto Sans"/>
               </a:rPr>
-              <a:t>[1] Stanford CRFM, HELM Classic v0.4.0, TwitterAAE. 公開実行suite v0.3.0。 instance: aa/id15055（HELM内ID）</a:t>
-            </a:r>
-          </a:p>
-          <a:p>
-            <a:pPr>
-              <a:lnSpc>
-                <a:spcPts val="940"/>
-              </a:lnSpc>
-              <a:buNone/>
-              <a:defRPr sz="810" b="0">
-                <a:solidFill>
-                  <a:srgbClr val="303437"/>
-                </a:solidFill>
-                <a:latin typeface="Noto Sans"/>
-              </a:defRPr>
-            </a:pPr>
+              <a:t>[1] Stanford CRFM. HELM Classic v0.4.0 — TwitterAAE.  </a:t>
+            </a:r>
             <a:r>
               <a:rPr sz="810" b="0" lang="ja-JP" altLang="en-US">
                 <a:solidFill>

</xml_diff>